<commit_message>
Version to be discussed at the side meeting
Includes all the comments received so far
</commit_message>
<xml_diff>
--- a/ietf-125-fann-slides.pptx
+++ b/ietf-125-fann-slides.pptx
@@ -6,7 +6,7 @@
     <p:sldMasterId id="2147483665" r:id="rId2"/>
   </p:sldMasterIdLst>
   <p:notesMasterIdLst>
-    <p:notesMasterId r:id="rId13"/>
+    <p:notesMasterId r:id="rId21"/>
   </p:notesMasterIdLst>
   <p:sldIdLst>
     <p:sldId id="256" r:id="rId3"/>
@@ -17,53 +17,61 @@
     <p:sldId id="261" r:id="rId8"/>
     <p:sldId id="262" r:id="rId9"/>
     <p:sldId id="263" r:id="rId10"/>
-    <p:sldId id="265" r:id="rId11"/>
-    <p:sldId id="264" r:id="rId12"/>
+    <p:sldId id="269" r:id="rId11"/>
+    <p:sldId id="265" r:id="rId12"/>
+    <p:sldId id="268" r:id="rId13"/>
+    <p:sldId id="270" r:id="rId14"/>
+    <p:sldId id="271" r:id="rId15"/>
+    <p:sldId id="272" r:id="rId16"/>
+    <p:sldId id="273" r:id="rId17"/>
+    <p:sldId id="274" r:id="rId18"/>
+    <p:sldId id="275" r:id="rId19"/>
+    <p:sldId id="264" r:id="rId20"/>
   </p:sldIdLst>
   <p:sldSz cx="9144000" cy="5143500" type="screen16x9"/>
   <p:notesSz cx="6858000" cy="9144000"/>
   <p:embeddedFontLst>
     <p:embeddedFont>
       <p:font typeface="Inter" panose="02000503000000020004" pitchFamily="2" charset="0"/>
-      <p:regular r:id="rId14"/>
-      <p:bold r:id="rId15"/>
-      <p:italic r:id="rId16"/>
-      <p:boldItalic r:id="rId17"/>
-    </p:embeddedFont>
-    <p:embeddedFont>
-      <p:font typeface="Montserrat" pitchFamily="2" charset="77"/>
-      <p:regular r:id="rId18"/>
-      <p:bold r:id="rId19"/>
-      <p:italic r:id="rId20"/>
-      <p:boldItalic r:id="rId21"/>
-    </p:embeddedFont>
-    <p:embeddedFont>
-      <p:font typeface="Open Sans" panose="020B0606030504020204" pitchFamily="34" charset="0"/>
       <p:regular r:id="rId22"/>
       <p:bold r:id="rId23"/>
       <p:italic r:id="rId24"/>
       <p:boldItalic r:id="rId25"/>
     </p:embeddedFont>
     <p:embeddedFont>
-      <p:font typeface="Open Sans Medium" pitchFamily="2" charset="0"/>
+      <p:font typeface="Montserrat" pitchFamily="2" charset="77"/>
       <p:regular r:id="rId26"/>
       <p:bold r:id="rId27"/>
       <p:italic r:id="rId28"/>
       <p:boldItalic r:id="rId29"/>
     </p:embeddedFont>
     <p:embeddedFont>
-      <p:font typeface="Open Sans SemiBold" panose="020B0706030804020204" pitchFamily="34" charset="0"/>
+      <p:font typeface="Open Sans" panose="020B0606030504020204" pitchFamily="34" charset="0"/>
       <p:regular r:id="rId30"/>
       <p:bold r:id="rId31"/>
       <p:italic r:id="rId32"/>
       <p:boldItalic r:id="rId33"/>
     </p:embeddedFont>
     <p:embeddedFont>
-      <p:font typeface="Roboto" panose="02000000000000000000" pitchFamily="2" charset="0"/>
+      <p:font typeface="Open Sans Medium" pitchFamily="2" charset="0"/>
       <p:regular r:id="rId34"/>
       <p:bold r:id="rId35"/>
       <p:italic r:id="rId36"/>
       <p:boldItalic r:id="rId37"/>
+    </p:embeddedFont>
+    <p:embeddedFont>
+      <p:font typeface="Open Sans SemiBold" panose="020B0706030804020204" pitchFamily="34" charset="0"/>
+      <p:regular r:id="rId38"/>
+      <p:bold r:id="rId39"/>
+      <p:italic r:id="rId40"/>
+      <p:boldItalic r:id="rId41"/>
+    </p:embeddedFont>
+    <p:embeddedFont>
+      <p:font typeface="Roboto" pitchFamily="2" charset="0"/>
+      <p:regular r:id="rId42"/>
+      <p:bold r:id="rId43"/>
+      <p:italic r:id="rId44"/>
+      <p:boldItalic r:id="rId45"/>
     </p:embeddedFont>
   </p:embeddedFontLst>
   <p:defaultTextStyle>
@@ -16835,6 +16843,1836 @@
         <p:cNvPr id="1" name="">
           <a:extLst>
             <a:ext uri="{FF2B5EF4-FFF2-40B4-BE49-F238E27FC236}">
+              <a16:creationId xmlns:a16="http://schemas.microsoft.com/office/drawing/2014/main" id="{2D44A6CC-3F0E-4271-B01F-5FDC554B2AF0}"/>
+            </a:ext>
+          </a:extLst>
+        </p:cNvPr>
+        <p:cNvGrpSpPr/>
+        <p:nvPr/>
+      </p:nvGrpSpPr>
+      <p:grpSpPr>
+        <a:xfrm>
+          <a:off x="0" y="0"/>
+          <a:ext cx="0" cy="0"/>
+          <a:chOff x="0" y="0"/>
+          <a:chExt cx="0" cy="0"/>
+        </a:xfrm>
+      </p:grpSpPr>
+      <p:sp>
+        <p:nvSpPr>
+          <p:cNvPr id="2" name="Title 1">
+            <a:extLst>
+              <a:ext uri="{FF2B5EF4-FFF2-40B4-BE49-F238E27FC236}">
+                <a16:creationId xmlns:a16="http://schemas.microsoft.com/office/drawing/2014/main" id="{587A217E-1F63-F22E-47EF-529A2F51477F}"/>
+              </a:ext>
+            </a:extLst>
+          </p:cNvPr>
+          <p:cNvSpPr>
+            <a:spLocks noGrp="1"/>
+          </p:cNvSpPr>
+          <p:nvPr>
+            <p:ph type="title"/>
+          </p:nvPr>
+        </p:nvSpPr>
+        <p:spPr/>
+        <p:txBody>
+          <a:bodyPr/>
+          <a:lstStyle/>
+          <a:p>
+            <a:r>
+              <a:rPr lang="en-US" dirty="0"/>
+              <a:t>FANN charter text discussion </a:t>
+            </a:r>
+            <a:r>
+              <a:rPr lang="en-US" b="1" dirty="0"/>
+              <a:t>Acknowledgements</a:t>
+            </a:r>
+          </a:p>
+        </p:txBody>
+      </p:sp>
+      <p:sp>
+        <p:nvSpPr>
+          <p:cNvPr id="4" name="Slide Number Placeholder 3">
+            <a:extLst>
+              <a:ext uri="{FF2B5EF4-FFF2-40B4-BE49-F238E27FC236}">
+                <a16:creationId xmlns:a16="http://schemas.microsoft.com/office/drawing/2014/main" id="{D352032F-3F3B-B75A-E937-3D05E41AEE62}"/>
+              </a:ext>
+            </a:extLst>
+          </p:cNvPr>
+          <p:cNvSpPr>
+            <a:spLocks noGrp="1"/>
+          </p:cNvSpPr>
+          <p:nvPr>
+            <p:ph type="sldNum" idx="12"/>
+          </p:nvPr>
+        </p:nvSpPr>
+        <p:spPr/>
+        <p:txBody>
+          <a:bodyPr/>
+          <a:lstStyle/>
+          <a:p>
+            <a:pPr marL="0" lvl="0" indent="0" algn="l" rtl="0">
+              <a:spcBef>
+                <a:spcPts val="0"/>
+              </a:spcBef>
+              <a:spcAft>
+                <a:spcPts val="0"/>
+              </a:spcAft>
+              <a:buNone/>
+            </a:pPr>
+            <a:fld id="{00000000-1234-1234-1234-123412341234}" type="slidenum">
+              <a:rPr lang="en-US" smtClean="0"/>
+              <a:t>10</a:t>
+            </a:fld>
+            <a:endParaRPr lang="en-US"/>
+          </a:p>
+        </p:txBody>
+      </p:sp>
+      <p:sp>
+        <p:nvSpPr>
+          <p:cNvPr id="6" name="Text Placeholder 5">
+            <a:extLst>
+              <a:ext uri="{FF2B5EF4-FFF2-40B4-BE49-F238E27FC236}">
+                <a16:creationId xmlns:a16="http://schemas.microsoft.com/office/drawing/2014/main" id="{66FA077B-8A48-942A-00C5-E6BCC4EB33BB}"/>
+              </a:ext>
+            </a:extLst>
+          </p:cNvPr>
+          <p:cNvSpPr>
+            <a:spLocks noGrp="1"/>
+          </p:cNvSpPr>
+          <p:nvPr>
+            <p:ph type="body" idx="1"/>
+          </p:nvPr>
+        </p:nvSpPr>
+        <p:spPr>
+          <a:xfrm>
+            <a:off x="538800" y="1802552"/>
+            <a:ext cx="8066400" cy="2710125"/>
+          </a:xfrm>
+        </p:spPr>
+        <p:txBody>
+          <a:bodyPr/>
+          <a:lstStyle/>
+          <a:p>
+            <a:r>
+              <a:rPr lang="en-US" dirty="0"/>
+              <a:t>Thanks to Adrian Farrel, </a:t>
+            </a:r>
+            <a:r>
+              <a:rPr lang="en-CA" dirty="0"/>
+              <a:t>Joel Halpern</a:t>
+            </a:r>
+            <a:r>
+              <a:rPr lang="en-US" dirty="0"/>
+              <a:t>, </a:t>
+            </a:r>
+            <a:r>
+              <a:rPr lang="en-CA" dirty="0"/>
+              <a:t>Tal Mizrahi </a:t>
+            </a:r>
+            <a:r>
+              <a:rPr lang="en-US" dirty="0"/>
+              <a:t>, </a:t>
+            </a:r>
+            <a:r>
+              <a:rPr lang="en-CA" dirty="0" err="1"/>
+              <a:t>Yongqing</a:t>
+            </a:r>
+            <a:r>
+              <a:rPr lang="en-CA" dirty="0"/>
+              <a:t> Zhu, Carlos J, Bernardos, Jiayuan Hu, et al.,  </a:t>
+            </a:r>
+            <a:r>
+              <a:rPr lang="en-US" dirty="0"/>
+              <a:t>for the review of the Charter text on the mailing list</a:t>
+            </a:r>
+          </a:p>
+          <a:p>
+            <a:endParaRPr lang="en-US" dirty="0"/>
+          </a:p>
+          <a:p>
+            <a:r>
+              <a:rPr lang="en-US" dirty="0"/>
+              <a:t>Thanks to Jie Dong for addressing many review comments received – updates are work in progress</a:t>
+            </a:r>
+          </a:p>
+        </p:txBody>
+      </p:sp>
+    </p:spTree>
+    <p:extLst>
+      <p:ext uri="{BB962C8B-B14F-4D97-AF65-F5344CB8AC3E}">
+        <p14:creationId xmlns:p14="http://schemas.microsoft.com/office/powerpoint/2010/main" val="3462364297"/>
+      </p:ext>
+    </p:extLst>
+  </p:cSld>
+  <p:clrMapOvr>
+    <a:masterClrMapping/>
+  </p:clrMapOvr>
+</p:sld>
+</file>
+
+<file path=ppt/slides/slide11.xml><?xml version="1.0" encoding="utf-8"?>
+<p:sld xmlns:a="http://schemas.openxmlformats.org/drawingml/2006/main" xmlns:r="http://schemas.openxmlformats.org/officeDocument/2006/relationships" xmlns:p="http://schemas.openxmlformats.org/presentationml/2006/main">
+  <p:cSld>
+    <p:spTree>
+      <p:nvGrpSpPr>
+        <p:cNvPr id="1" name="">
+          <a:extLst>
+            <a:ext uri="{FF2B5EF4-FFF2-40B4-BE49-F238E27FC236}">
+              <a16:creationId xmlns:a16="http://schemas.microsoft.com/office/drawing/2014/main" id="{3AC7DBBB-229F-A946-CCB0-7A00074B4C1F}"/>
+            </a:ext>
+          </a:extLst>
+        </p:cNvPr>
+        <p:cNvGrpSpPr/>
+        <p:nvPr/>
+      </p:nvGrpSpPr>
+      <p:grpSpPr>
+        <a:xfrm>
+          <a:off x="0" y="0"/>
+          <a:ext cx="0" cy="0"/>
+          <a:chOff x="0" y="0"/>
+          <a:chExt cx="0" cy="0"/>
+        </a:xfrm>
+      </p:grpSpPr>
+      <p:sp>
+        <p:nvSpPr>
+          <p:cNvPr id="2" name="Title 1">
+            <a:extLst>
+              <a:ext uri="{FF2B5EF4-FFF2-40B4-BE49-F238E27FC236}">
+                <a16:creationId xmlns:a16="http://schemas.microsoft.com/office/drawing/2014/main" id="{37E4EED8-209B-8394-328E-F884CE505F40}"/>
+              </a:ext>
+            </a:extLst>
+          </p:cNvPr>
+          <p:cNvSpPr>
+            <a:spLocks noGrp="1"/>
+          </p:cNvSpPr>
+          <p:nvPr>
+            <p:ph type="title"/>
+          </p:nvPr>
+        </p:nvSpPr>
+        <p:spPr/>
+        <p:txBody>
+          <a:bodyPr/>
+          <a:lstStyle/>
+          <a:p>
+            <a:r>
+              <a:rPr lang="en-US" dirty="0"/>
+              <a:t>FANN charter text discussion</a:t>
+            </a:r>
+            <a:br>
+              <a:rPr lang="en-US" dirty="0"/>
+            </a:br>
+            <a:r>
+              <a:rPr lang="en-US" b="1" dirty="0"/>
+              <a:t>Open issues</a:t>
+            </a:r>
+          </a:p>
+        </p:txBody>
+      </p:sp>
+      <p:sp>
+        <p:nvSpPr>
+          <p:cNvPr id="4" name="Slide Number Placeholder 3">
+            <a:extLst>
+              <a:ext uri="{FF2B5EF4-FFF2-40B4-BE49-F238E27FC236}">
+                <a16:creationId xmlns:a16="http://schemas.microsoft.com/office/drawing/2014/main" id="{F6B15CEE-AFD6-783D-CFAD-2BC37FA82AC6}"/>
+              </a:ext>
+            </a:extLst>
+          </p:cNvPr>
+          <p:cNvSpPr>
+            <a:spLocks noGrp="1"/>
+          </p:cNvSpPr>
+          <p:nvPr>
+            <p:ph type="sldNum" idx="12"/>
+          </p:nvPr>
+        </p:nvSpPr>
+        <p:spPr/>
+        <p:txBody>
+          <a:bodyPr/>
+          <a:lstStyle/>
+          <a:p>
+            <a:pPr marL="0" lvl="0" indent="0" algn="l" rtl="0">
+              <a:spcBef>
+                <a:spcPts val="0"/>
+              </a:spcBef>
+              <a:spcAft>
+                <a:spcPts val="0"/>
+              </a:spcAft>
+              <a:buNone/>
+            </a:pPr>
+            <a:fld id="{00000000-1234-1234-1234-123412341234}" type="slidenum">
+              <a:rPr lang="en-US" smtClean="0"/>
+              <a:t>11</a:t>
+            </a:fld>
+            <a:endParaRPr lang="en-US"/>
+          </a:p>
+        </p:txBody>
+      </p:sp>
+      <p:sp>
+        <p:nvSpPr>
+          <p:cNvPr id="6" name="Text Placeholder 5">
+            <a:extLst>
+              <a:ext uri="{FF2B5EF4-FFF2-40B4-BE49-F238E27FC236}">
+                <a16:creationId xmlns:a16="http://schemas.microsoft.com/office/drawing/2014/main" id="{3635A212-D261-672A-C740-138F850B7DC9}"/>
+              </a:ext>
+            </a:extLst>
+          </p:cNvPr>
+          <p:cNvSpPr>
+            <a:spLocks noGrp="1"/>
+          </p:cNvSpPr>
+          <p:nvPr>
+            <p:ph type="body" idx="1"/>
+          </p:nvPr>
+        </p:nvSpPr>
+        <p:spPr>
+          <a:xfrm>
+            <a:off x="538800" y="1802552"/>
+            <a:ext cx="8066400" cy="2710125"/>
+          </a:xfrm>
+        </p:spPr>
+        <p:txBody>
+          <a:bodyPr/>
+          <a:lstStyle/>
+          <a:p>
+            <a:r>
+              <a:rPr lang="en-US" dirty="0"/>
+              <a:t>Clarify base requirements – Adrian Farrel (</a:t>
+            </a:r>
+            <a:r>
+              <a:rPr lang="en-US" dirty="0">
+                <a:hlinkClick r:id="rId2"/>
+              </a:rPr>
+              <a:t>issue #8</a:t>
+            </a:r>
+            <a:r>
+              <a:rPr lang="en-US" dirty="0"/>
+              <a:t>)</a:t>
+            </a:r>
+          </a:p>
+          <a:p>
+            <a:pPr lvl="1">
+              <a:spcBef>
+                <a:spcPts val="0"/>
+              </a:spcBef>
+            </a:pPr>
+            <a:r>
+              <a:rPr lang="en-US" dirty="0"/>
+              <a:t>The text brings up DCs. Sure they are important, but the scope does not need to mention them.</a:t>
+            </a:r>
+          </a:p>
+          <a:p>
+            <a:pPr lvl="1">
+              <a:spcBef>
+                <a:spcPts val="0"/>
+              </a:spcBef>
+            </a:pPr>
+            <a:r>
+              <a:rPr lang="en-US" dirty="0"/>
+              <a:t>On the other hand, the scope should be more clear about the network services that the applications require and the issues that need to be survived.</a:t>
+            </a:r>
+          </a:p>
+          <a:p>
+            <a:r>
+              <a:rPr lang="en-US" dirty="0"/>
+              <a:t>Consider renaming FANN to FUN – Adrian Farrel (</a:t>
+            </a:r>
+            <a:r>
+              <a:rPr lang="en-US" dirty="0">
+                <a:hlinkClick r:id="rId3"/>
+              </a:rPr>
+              <a:t>issue #11</a:t>
+            </a:r>
+            <a:r>
+              <a:rPr lang="en-US" dirty="0"/>
+              <a:t>)</a:t>
+            </a:r>
+          </a:p>
+          <a:p>
+            <a:pPr lvl="1">
+              <a:spcBef>
+                <a:spcPts val="0"/>
+              </a:spcBef>
+            </a:pPr>
+            <a:r>
+              <a:rPr lang="en-US" dirty="0"/>
+              <a:t>I'm not a fan of FANN. FUN would be more fun.</a:t>
+            </a:r>
+          </a:p>
+          <a:p>
+            <a:pPr lvl="1">
+              <a:spcBef>
+                <a:spcPts val="0"/>
+              </a:spcBef>
+            </a:pPr>
+            <a:r>
+              <a:rPr lang="en-US" dirty="0"/>
+              <a:t>Fast Unrestricted Notifications</a:t>
+            </a:r>
+          </a:p>
+        </p:txBody>
+      </p:sp>
+    </p:spTree>
+    <p:extLst>
+      <p:ext uri="{BB962C8B-B14F-4D97-AF65-F5344CB8AC3E}">
+        <p14:creationId xmlns:p14="http://schemas.microsoft.com/office/powerpoint/2010/main" val="3003668083"/>
+      </p:ext>
+    </p:extLst>
+  </p:cSld>
+  <p:clrMapOvr>
+    <a:masterClrMapping/>
+  </p:clrMapOvr>
+</p:sld>
+</file>
+
+<file path=ppt/slides/slide12.xml><?xml version="1.0" encoding="utf-8"?>
+<p:sld xmlns:a="http://schemas.openxmlformats.org/drawingml/2006/main" xmlns:r="http://schemas.openxmlformats.org/officeDocument/2006/relationships" xmlns:p="http://schemas.openxmlformats.org/presentationml/2006/main">
+  <p:cSld>
+    <p:spTree>
+      <p:nvGrpSpPr>
+        <p:cNvPr id="1" name="">
+          <a:extLst>
+            <a:ext uri="{FF2B5EF4-FFF2-40B4-BE49-F238E27FC236}">
+              <a16:creationId xmlns:a16="http://schemas.microsoft.com/office/drawing/2014/main" id="{BDA1159C-762D-4864-E97A-7EF9E719F546}"/>
+            </a:ext>
+          </a:extLst>
+        </p:cNvPr>
+        <p:cNvGrpSpPr/>
+        <p:nvPr/>
+      </p:nvGrpSpPr>
+      <p:grpSpPr>
+        <a:xfrm>
+          <a:off x="0" y="0"/>
+          <a:ext cx="0" cy="0"/>
+          <a:chOff x="0" y="0"/>
+          <a:chExt cx="0" cy="0"/>
+        </a:xfrm>
+      </p:grpSpPr>
+      <p:sp>
+        <p:nvSpPr>
+          <p:cNvPr id="2" name="Title 1">
+            <a:extLst>
+              <a:ext uri="{FF2B5EF4-FFF2-40B4-BE49-F238E27FC236}">
+                <a16:creationId xmlns:a16="http://schemas.microsoft.com/office/drawing/2014/main" id="{BA089D24-2129-BFE6-AF54-1F344475EA78}"/>
+              </a:ext>
+            </a:extLst>
+          </p:cNvPr>
+          <p:cNvSpPr>
+            <a:spLocks noGrp="1"/>
+          </p:cNvSpPr>
+          <p:nvPr>
+            <p:ph type="title"/>
+          </p:nvPr>
+        </p:nvSpPr>
+        <p:spPr/>
+        <p:txBody>
+          <a:bodyPr/>
+          <a:lstStyle/>
+          <a:p>
+            <a:r>
+              <a:rPr lang="en-US" dirty="0"/>
+              <a:t>FANN charter text discussion</a:t>
+            </a:r>
+            <a:br>
+              <a:rPr lang="en-US" dirty="0"/>
+            </a:br>
+            <a:r>
+              <a:rPr lang="en-US" b="1" dirty="0"/>
+              <a:t>Open issues</a:t>
+            </a:r>
+            <a:endParaRPr lang="en-US" dirty="0"/>
+          </a:p>
+        </p:txBody>
+      </p:sp>
+      <p:sp>
+        <p:nvSpPr>
+          <p:cNvPr id="4" name="Slide Number Placeholder 3">
+            <a:extLst>
+              <a:ext uri="{FF2B5EF4-FFF2-40B4-BE49-F238E27FC236}">
+                <a16:creationId xmlns:a16="http://schemas.microsoft.com/office/drawing/2014/main" id="{F020DC95-469A-D509-8D52-5CCF9BF57358}"/>
+              </a:ext>
+            </a:extLst>
+          </p:cNvPr>
+          <p:cNvSpPr>
+            <a:spLocks noGrp="1"/>
+          </p:cNvSpPr>
+          <p:nvPr>
+            <p:ph type="sldNum" idx="12"/>
+          </p:nvPr>
+        </p:nvSpPr>
+        <p:spPr/>
+        <p:txBody>
+          <a:bodyPr/>
+          <a:lstStyle/>
+          <a:p>
+            <a:pPr marL="0" lvl="0" indent="0" algn="l" rtl="0">
+              <a:spcBef>
+                <a:spcPts val="0"/>
+              </a:spcBef>
+              <a:spcAft>
+                <a:spcPts val="0"/>
+              </a:spcAft>
+              <a:buNone/>
+            </a:pPr>
+            <a:fld id="{00000000-1234-1234-1234-123412341234}" type="slidenum">
+              <a:rPr lang="en-US" smtClean="0"/>
+              <a:t>12</a:t>
+            </a:fld>
+            <a:endParaRPr lang="en-US"/>
+          </a:p>
+        </p:txBody>
+      </p:sp>
+      <p:sp>
+        <p:nvSpPr>
+          <p:cNvPr id="6" name="Text Placeholder 5">
+            <a:extLst>
+              <a:ext uri="{FF2B5EF4-FFF2-40B4-BE49-F238E27FC236}">
+                <a16:creationId xmlns:a16="http://schemas.microsoft.com/office/drawing/2014/main" id="{400C410B-2A0B-49D3-B36A-F07388101265}"/>
+              </a:ext>
+            </a:extLst>
+          </p:cNvPr>
+          <p:cNvSpPr>
+            <a:spLocks noGrp="1"/>
+          </p:cNvSpPr>
+          <p:nvPr>
+            <p:ph type="body" idx="1"/>
+          </p:nvPr>
+        </p:nvSpPr>
+        <p:spPr>
+          <a:xfrm>
+            <a:off x="538800" y="1802552"/>
+            <a:ext cx="7942260" cy="2710125"/>
+          </a:xfrm>
+        </p:spPr>
+        <p:txBody>
+          <a:bodyPr/>
+          <a:lstStyle/>
+          <a:p>
+            <a:r>
+              <a:rPr lang="en-US" sz="1400" dirty="0"/>
+              <a:t>Who notifies whom? – Adrian Farrel (</a:t>
+            </a:r>
+            <a:r>
+              <a:rPr lang="en-US" sz="1400" dirty="0">
+                <a:hlinkClick r:id="rId2"/>
+              </a:rPr>
+              <a:t>issue #16</a:t>
+            </a:r>
+            <a:r>
+              <a:rPr lang="en-US" sz="1400" dirty="0"/>
+              <a:t>)</a:t>
+            </a:r>
+          </a:p>
+          <a:p>
+            <a:pPr lvl="1">
+              <a:spcBef>
+                <a:spcPts val="0"/>
+              </a:spcBef>
+            </a:pPr>
+            <a:r>
+              <a:rPr lang="en-US" sz="1100" dirty="0"/>
+              <a:t>The text has:</a:t>
+            </a:r>
+          </a:p>
+          <a:p>
+            <a:pPr lvl="2">
+              <a:spcBef>
+                <a:spcPts val="0"/>
+              </a:spcBef>
+            </a:pPr>
+            <a:r>
+              <a:rPr lang="en-US" sz="1100" dirty="0"/>
+              <a:t>The </a:t>
+            </a:r>
+            <a:r>
+              <a:rPr lang="en-US" sz="1100" dirty="0" err="1"/>
+              <a:t>FAst</a:t>
+            </a:r>
+            <a:r>
+              <a:rPr lang="en-US" sz="1100" dirty="0"/>
+              <a:t> Network Notification (FANN) Working Group is chartered to specify the protocols, mechanisms, and procedures for on-demand, fast notifications of fine-grained network status information, which allow network nodes that may take response actions to learn quickly about the network conditions.</a:t>
+            </a:r>
+          </a:p>
+          <a:p>
+            <a:pPr lvl="1">
+              <a:spcBef>
+                <a:spcPts val="0"/>
+              </a:spcBef>
+            </a:pPr>
+            <a:r>
+              <a:rPr lang="en-US" sz="1100" dirty="0"/>
+              <a:t>This is fine except it leaves out the agents. Who does what?</a:t>
+            </a:r>
+          </a:p>
+          <a:p>
+            <a:pPr lvl="1">
+              <a:spcBef>
+                <a:spcPts val="0"/>
+              </a:spcBef>
+            </a:pPr>
+            <a:r>
+              <a:rPr lang="en-US" sz="1100" dirty="0"/>
+              <a:t>It is fairly clear that it is the network elements that do the notification. We can easily clarify that.</a:t>
+            </a:r>
+          </a:p>
+          <a:p>
+            <a:pPr lvl="1">
+              <a:spcBef>
+                <a:spcPts val="0"/>
+              </a:spcBef>
+            </a:pPr>
+            <a:r>
+              <a:rPr lang="en-US" sz="1100" dirty="0"/>
+              <a:t>Who they notify is a trickier question, but it is fundamental to the work that has to be done by the WG</a:t>
+            </a:r>
+          </a:p>
+          <a:p>
+            <a:pPr lvl="2">
+              <a:spcBef>
+                <a:spcPts val="0"/>
+              </a:spcBef>
+            </a:pPr>
+            <a:r>
+              <a:rPr lang="en-US" sz="1100" dirty="0"/>
+              <a:t>Notifying the neighbor is one thing.</a:t>
+            </a:r>
+          </a:p>
+          <a:p>
+            <a:pPr lvl="2">
+              <a:spcBef>
+                <a:spcPts val="0"/>
+              </a:spcBef>
+            </a:pPr>
+            <a:r>
+              <a:rPr lang="en-US" sz="1100" dirty="0"/>
+              <a:t>Notifying the head of a path or even all the notes on a path may be possible in some systems.</a:t>
+            </a:r>
+          </a:p>
+          <a:p>
+            <a:pPr lvl="2">
+              <a:spcBef>
+                <a:spcPts val="0"/>
+              </a:spcBef>
+            </a:pPr>
+            <a:r>
+              <a:rPr lang="en-US" sz="1100" dirty="0"/>
+              <a:t>Or perhaps we want to notify a controller or fault correlation point.</a:t>
+            </a:r>
+          </a:p>
+          <a:p>
+            <a:pPr lvl="2">
+              <a:spcBef>
+                <a:spcPts val="0"/>
+              </a:spcBef>
+            </a:pPr>
+            <a:r>
+              <a:rPr lang="en-US" sz="1100" dirty="0"/>
+              <a:t>And (probably quite important) we may need to notify multiple places in the network where traffic steering decisions are made.</a:t>
+            </a:r>
+          </a:p>
+        </p:txBody>
+      </p:sp>
+    </p:spTree>
+    <p:extLst>
+      <p:ext uri="{BB962C8B-B14F-4D97-AF65-F5344CB8AC3E}">
+        <p14:creationId xmlns:p14="http://schemas.microsoft.com/office/powerpoint/2010/main" val="2339125643"/>
+      </p:ext>
+    </p:extLst>
+  </p:cSld>
+  <p:clrMapOvr>
+    <a:masterClrMapping/>
+  </p:clrMapOvr>
+</p:sld>
+</file>
+
+<file path=ppt/slides/slide13.xml><?xml version="1.0" encoding="utf-8"?>
+<p:sld xmlns:a="http://schemas.openxmlformats.org/drawingml/2006/main" xmlns:r="http://schemas.openxmlformats.org/officeDocument/2006/relationships" xmlns:p="http://schemas.openxmlformats.org/presentationml/2006/main">
+  <p:cSld>
+    <p:spTree>
+      <p:nvGrpSpPr>
+        <p:cNvPr id="1" name="">
+          <a:extLst>
+            <a:ext uri="{FF2B5EF4-FFF2-40B4-BE49-F238E27FC236}">
+              <a16:creationId xmlns:a16="http://schemas.microsoft.com/office/drawing/2014/main" id="{581E4D5F-45FD-E088-FB06-E5B82BA51793}"/>
+            </a:ext>
+          </a:extLst>
+        </p:cNvPr>
+        <p:cNvGrpSpPr/>
+        <p:nvPr/>
+      </p:nvGrpSpPr>
+      <p:grpSpPr>
+        <a:xfrm>
+          <a:off x="0" y="0"/>
+          <a:ext cx="0" cy="0"/>
+          <a:chOff x="0" y="0"/>
+          <a:chExt cx="0" cy="0"/>
+        </a:xfrm>
+      </p:grpSpPr>
+      <p:sp>
+        <p:nvSpPr>
+          <p:cNvPr id="2" name="Title 1">
+            <a:extLst>
+              <a:ext uri="{FF2B5EF4-FFF2-40B4-BE49-F238E27FC236}">
+                <a16:creationId xmlns:a16="http://schemas.microsoft.com/office/drawing/2014/main" id="{ABBEB61A-5AD6-2727-5ED4-A611D5C1F89A}"/>
+              </a:ext>
+            </a:extLst>
+          </p:cNvPr>
+          <p:cNvSpPr>
+            <a:spLocks noGrp="1"/>
+          </p:cNvSpPr>
+          <p:nvPr>
+            <p:ph type="title"/>
+          </p:nvPr>
+        </p:nvSpPr>
+        <p:spPr/>
+        <p:txBody>
+          <a:bodyPr/>
+          <a:lstStyle/>
+          <a:p>
+            <a:r>
+              <a:rPr lang="en-US" dirty="0"/>
+              <a:t>FANN charter text discussion</a:t>
+            </a:r>
+            <a:br>
+              <a:rPr lang="en-US" dirty="0"/>
+            </a:br>
+            <a:r>
+              <a:rPr lang="en-US" b="1" dirty="0"/>
+              <a:t>Open issues</a:t>
+            </a:r>
+            <a:endParaRPr lang="en-US" dirty="0"/>
+          </a:p>
+        </p:txBody>
+      </p:sp>
+      <p:sp>
+        <p:nvSpPr>
+          <p:cNvPr id="4" name="Slide Number Placeholder 3">
+            <a:extLst>
+              <a:ext uri="{FF2B5EF4-FFF2-40B4-BE49-F238E27FC236}">
+                <a16:creationId xmlns:a16="http://schemas.microsoft.com/office/drawing/2014/main" id="{C90AAB81-3CC3-E3D1-FB8A-C62F56F8CEEE}"/>
+              </a:ext>
+            </a:extLst>
+          </p:cNvPr>
+          <p:cNvSpPr>
+            <a:spLocks noGrp="1"/>
+          </p:cNvSpPr>
+          <p:nvPr>
+            <p:ph type="sldNum" idx="12"/>
+          </p:nvPr>
+        </p:nvSpPr>
+        <p:spPr/>
+        <p:txBody>
+          <a:bodyPr/>
+          <a:lstStyle/>
+          <a:p>
+            <a:pPr marL="0" lvl="0" indent="0" algn="l" rtl="0">
+              <a:spcBef>
+                <a:spcPts val="0"/>
+              </a:spcBef>
+              <a:spcAft>
+                <a:spcPts val="0"/>
+              </a:spcAft>
+              <a:buNone/>
+            </a:pPr>
+            <a:fld id="{00000000-1234-1234-1234-123412341234}" type="slidenum">
+              <a:rPr lang="en-US" smtClean="0"/>
+              <a:t>13</a:t>
+            </a:fld>
+            <a:endParaRPr lang="en-US"/>
+          </a:p>
+        </p:txBody>
+      </p:sp>
+      <p:sp>
+        <p:nvSpPr>
+          <p:cNvPr id="6" name="Text Placeholder 5">
+            <a:extLst>
+              <a:ext uri="{FF2B5EF4-FFF2-40B4-BE49-F238E27FC236}">
+                <a16:creationId xmlns:a16="http://schemas.microsoft.com/office/drawing/2014/main" id="{D035634A-DF2C-95E5-87A5-736DEEDC4B89}"/>
+              </a:ext>
+            </a:extLst>
+          </p:cNvPr>
+          <p:cNvSpPr>
+            <a:spLocks noGrp="1"/>
+          </p:cNvSpPr>
+          <p:nvPr>
+            <p:ph type="body" idx="1"/>
+          </p:nvPr>
+        </p:nvSpPr>
+        <p:spPr>
+          <a:xfrm>
+            <a:off x="538800" y="1802552"/>
+            <a:ext cx="7690800" cy="2710125"/>
+          </a:xfrm>
+        </p:spPr>
+        <p:txBody>
+          <a:bodyPr/>
+          <a:lstStyle/>
+          <a:p>
+            <a:r>
+              <a:rPr lang="en-US" sz="1400" dirty="0"/>
+              <a:t>The relationship with other working groups needs refinement – Adrian Farrel (</a:t>
+            </a:r>
+            <a:r>
+              <a:rPr lang="en-US" sz="1400" dirty="0">
+                <a:hlinkClick r:id="rId2"/>
+              </a:rPr>
+              <a:t>issue #18</a:t>
+            </a:r>
+            <a:r>
+              <a:rPr lang="en-US" sz="1400" dirty="0"/>
+              <a:t>)</a:t>
+            </a:r>
+          </a:p>
+          <a:p>
+            <a:pPr lvl="1">
+              <a:spcBef>
+                <a:spcPts val="0"/>
+              </a:spcBef>
+            </a:pPr>
+            <a:r>
+              <a:rPr lang="en-US" sz="1100" dirty="0"/>
+              <a:t>Some clarifications of why TEAS and RTGWG need cooperation - this is just tidying the words.</a:t>
+            </a:r>
+          </a:p>
+          <a:p>
+            <a:pPr lvl="1">
+              <a:spcBef>
+                <a:spcPts val="0"/>
+              </a:spcBef>
+            </a:pPr>
+            <a:r>
+              <a:rPr lang="en-US" sz="1100" dirty="0"/>
+              <a:t>Don't forget the important roles of NMOP and IVY in this work.</a:t>
+            </a:r>
+          </a:p>
+          <a:p>
+            <a:r>
+              <a:rPr lang="en-US" sz="1400" dirty="0"/>
+              <a:t>Focus the scope – Adrian Farrel (</a:t>
+            </a:r>
+            <a:r>
+              <a:rPr lang="en-US" sz="1400" dirty="0">
+                <a:hlinkClick r:id="rId3"/>
+              </a:rPr>
+              <a:t>issue #20</a:t>
+            </a:r>
+            <a:r>
+              <a:rPr lang="en-US" sz="1400" dirty="0"/>
+              <a:t>)</a:t>
+            </a:r>
+          </a:p>
+          <a:p>
+            <a:pPr lvl="1">
+              <a:spcBef>
+                <a:spcPts val="0"/>
+              </a:spcBef>
+            </a:pPr>
+            <a:r>
+              <a:rPr lang="en-US" sz="1100" dirty="0"/>
+              <a:t>Currently the scope says inter-DC WAN and intra-DC.</a:t>
+            </a:r>
+          </a:p>
+          <a:p>
+            <a:pPr lvl="1">
+              <a:spcBef>
+                <a:spcPts val="0"/>
+              </a:spcBef>
+            </a:pPr>
+            <a:r>
+              <a:rPr lang="en-US" sz="1100" dirty="0"/>
+              <a:t>While it is possible that a single solution will fit both cases, the text goes on to note that it might not.</a:t>
+            </a:r>
+          </a:p>
+          <a:p>
+            <a:pPr lvl="1">
+              <a:spcBef>
+                <a:spcPts val="0"/>
+              </a:spcBef>
+            </a:pPr>
+            <a:r>
+              <a:rPr lang="en-US" sz="1100" dirty="0"/>
+              <a:t>We need to focus our work by selecting our main target problem and observing that other scenarios might also be solved by our work.</a:t>
+            </a:r>
+          </a:p>
+          <a:p>
+            <a:pPr lvl="1">
+              <a:spcBef>
+                <a:spcPts val="0"/>
+              </a:spcBef>
+            </a:pPr>
+            <a:r>
+              <a:rPr lang="en-US" sz="1100" dirty="0"/>
+              <a:t>I suggest that we have (in order of priority):</a:t>
+            </a:r>
+          </a:p>
+          <a:p>
+            <a:pPr lvl="2">
+              <a:spcBef>
+                <a:spcPts val="0"/>
+              </a:spcBef>
+            </a:pPr>
+            <a:r>
+              <a:rPr lang="en-US" sz="1100" dirty="0"/>
+              <a:t>inter-DC WAN</a:t>
+            </a:r>
+          </a:p>
+          <a:p>
+            <a:pPr lvl="2">
+              <a:spcBef>
+                <a:spcPts val="0"/>
+              </a:spcBef>
+            </a:pPr>
+            <a:r>
+              <a:rPr lang="en-US" sz="1100" dirty="0"/>
+              <a:t>any other WAN use case</a:t>
+            </a:r>
+          </a:p>
+          <a:p>
+            <a:pPr lvl="2">
+              <a:spcBef>
+                <a:spcPts val="0"/>
+              </a:spcBef>
+            </a:pPr>
+            <a:r>
+              <a:rPr lang="en-US" sz="1100" dirty="0"/>
+              <a:t>intra-DC</a:t>
+            </a:r>
+          </a:p>
+          <a:p>
+            <a:pPr lvl="1">
+              <a:spcBef>
+                <a:spcPts val="0"/>
+              </a:spcBef>
+            </a:pPr>
+            <a:r>
+              <a:rPr lang="en-US" sz="1100" dirty="0"/>
+              <a:t>I also suggest that we can safely bundle 1 and 2, but that 3 should be marked as "if we get it for free, that is fine, but we won't target it."</a:t>
+            </a:r>
+          </a:p>
+        </p:txBody>
+      </p:sp>
+    </p:spTree>
+    <p:extLst>
+      <p:ext uri="{BB962C8B-B14F-4D97-AF65-F5344CB8AC3E}">
+        <p14:creationId xmlns:p14="http://schemas.microsoft.com/office/powerpoint/2010/main" val="4200629856"/>
+      </p:ext>
+    </p:extLst>
+  </p:cSld>
+  <p:clrMapOvr>
+    <a:masterClrMapping/>
+  </p:clrMapOvr>
+</p:sld>
+</file>
+
+<file path=ppt/slides/slide14.xml><?xml version="1.0" encoding="utf-8"?>
+<p:sld xmlns:a="http://schemas.openxmlformats.org/drawingml/2006/main" xmlns:r="http://schemas.openxmlformats.org/officeDocument/2006/relationships" xmlns:p="http://schemas.openxmlformats.org/presentationml/2006/main">
+  <p:cSld>
+    <p:spTree>
+      <p:nvGrpSpPr>
+        <p:cNvPr id="1" name="">
+          <a:extLst>
+            <a:ext uri="{FF2B5EF4-FFF2-40B4-BE49-F238E27FC236}">
+              <a16:creationId xmlns:a16="http://schemas.microsoft.com/office/drawing/2014/main" id="{22C7F9C9-9ABF-5643-DDEA-2DD4E449F51F}"/>
+            </a:ext>
+          </a:extLst>
+        </p:cNvPr>
+        <p:cNvGrpSpPr/>
+        <p:nvPr/>
+      </p:nvGrpSpPr>
+      <p:grpSpPr>
+        <a:xfrm>
+          <a:off x="0" y="0"/>
+          <a:ext cx="0" cy="0"/>
+          <a:chOff x="0" y="0"/>
+          <a:chExt cx="0" cy="0"/>
+        </a:xfrm>
+      </p:grpSpPr>
+      <p:sp>
+        <p:nvSpPr>
+          <p:cNvPr id="2" name="Title 1">
+            <a:extLst>
+              <a:ext uri="{FF2B5EF4-FFF2-40B4-BE49-F238E27FC236}">
+                <a16:creationId xmlns:a16="http://schemas.microsoft.com/office/drawing/2014/main" id="{80611410-E3B4-2A8D-3CAE-64AB22EFFE81}"/>
+              </a:ext>
+            </a:extLst>
+          </p:cNvPr>
+          <p:cNvSpPr>
+            <a:spLocks noGrp="1"/>
+          </p:cNvSpPr>
+          <p:nvPr>
+            <p:ph type="title"/>
+          </p:nvPr>
+        </p:nvSpPr>
+        <p:spPr/>
+        <p:txBody>
+          <a:bodyPr/>
+          <a:lstStyle/>
+          <a:p>
+            <a:r>
+              <a:rPr lang="en-US" dirty="0"/>
+              <a:t>FANN charter text discussion</a:t>
+            </a:r>
+            <a:br>
+              <a:rPr lang="en-US" dirty="0"/>
+            </a:br>
+            <a:r>
+              <a:rPr lang="en-US" b="1" dirty="0"/>
+              <a:t>Open issues</a:t>
+            </a:r>
+            <a:endParaRPr lang="en-US" dirty="0"/>
+          </a:p>
+        </p:txBody>
+      </p:sp>
+      <p:sp>
+        <p:nvSpPr>
+          <p:cNvPr id="4" name="Slide Number Placeholder 3">
+            <a:extLst>
+              <a:ext uri="{FF2B5EF4-FFF2-40B4-BE49-F238E27FC236}">
+                <a16:creationId xmlns:a16="http://schemas.microsoft.com/office/drawing/2014/main" id="{891F9F6B-A428-0E94-21C0-A5CF24470A28}"/>
+              </a:ext>
+            </a:extLst>
+          </p:cNvPr>
+          <p:cNvSpPr>
+            <a:spLocks noGrp="1"/>
+          </p:cNvSpPr>
+          <p:nvPr>
+            <p:ph type="sldNum" idx="12"/>
+          </p:nvPr>
+        </p:nvSpPr>
+        <p:spPr/>
+        <p:txBody>
+          <a:bodyPr/>
+          <a:lstStyle/>
+          <a:p>
+            <a:pPr marL="0" lvl="0" indent="0" algn="l" rtl="0">
+              <a:spcBef>
+                <a:spcPts val="0"/>
+              </a:spcBef>
+              <a:spcAft>
+                <a:spcPts val="0"/>
+              </a:spcAft>
+              <a:buNone/>
+            </a:pPr>
+            <a:fld id="{00000000-1234-1234-1234-123412341234}" type="slidenum">
+              <a:rPr lang="en-US" smtClean="0"/>
+              <a:t>14</a:t>
+            </a:fld>
+            <a:endParaRPr lang="en-US"/>
+          </a:p>
+        </p:txBody>
+      </p:sp>
+      <p:sp>
+        <p:nvSpPr>
+          <p:cNvPr id="6" name="Text Placeholder 5">
+            <a:extLst>
+              <a:ext uri="{FF2B5EF4-FFF2-40B4-BE49-F238E27FC236}">
+                <a16:creationId xmlns:a16="http://schemas.microsoft.com/office/drawing/2014/main" id="{B7A4D9B5-3B7A-2373-A105-92812DFE5744}"/>
+              </a:ext>
+            </a:extLst>
+          </p:cNvPr>
+          <p:cNvSpPr>
+            <a:spLocks noGrp="1"/>
+          </p:cNvSpPr>
+          <p:nvPr>
+            <p:ph type="body" idx="1"/>
+          </p:nvPr>
+        </p:nvSpPr>
+        <p:spPr>
+          <a:xfrm>
+            <a:off x="538800" y="1802552"/>
+            <a:ext cx="8066400" cy="2710125"/>
+          </a:xfrm>
+        </p:spPr>
+        <p:txBody>
+          <a:bodyPr/>
+          <a:lstStyle/>
+          <a:p>
+            <a:r>
+              <a:rPr lang="en-US" dirty="0"/>
+              <a:t>Refine work in Requirements and Gap Analysis deliverable – Adrian Farrel (</a:t>
+            </a:r>
+            <a:r>
+              <a:rPr lang="en-US" dirty="0">
+                <a:hlinkClick r:id="rId2"/>
+              </a:rPr>
+              <a:t>issue #24</a:t>
+            </a:r>
+            <a:r>
+              <a:rPr lang="en-US" dirty="0"/>
+              <a:t>)</a:t>
+            </a:r>
+          </a:p>
+          <a:p>
+            <a:pPr lvl="1">
+              <a:spcBef>
+                <a:spcPts val="0"/>
+              </a:spcBef>
+            </a:pPr>
+            <a:r>
+              <a:rPr lang="en-US" dirty="0"/>
+              <a:t>For each use case, also need to work out who collects and who consumes the information.</a:t>
+            </a:r>
+          </a:p>
+          <a:p>
+            <a:pPr lvl="1">
+              <a:spcBef>
+                <a:spcPts val="0"/>
+              </a:spcBef>
+            </a:pPr>
+            <a:r>
+              <a:rPr lang="en-US" dirty="0"/>
+              <a:t>For gap analysis, need to properly consider existing protocols.</a:t>
+            </a:r>
+          </a:p>
+          <a:p>
+            <a:r>
+              <a:rPr lang="en-US" dirty="0"/>
+              <a:t>Protocols deliverable needs work – Adrian Farrel (</a:t>
+            </a:r>
+            <a:r>
+              <a:rPr lang="en-US" dirty="0">
+                <a:hlinkClick r:id="rId3"/>
+              </a:rPr>
+              <a:t>issue #28</a:t>
+            </a:r>
+            <a:r>
+              <a:rPr lang="en-US" dirty="0"/>
+              <a:t>)</a:t>
+            </a:r>
+          </a:p>
+          <a:p>
+            <a:pPr lvl="1">
+              <a:spcBef>
+                <a:spcPts val="0"/>
+              </a:spcBef>
+            </a:pPr>
+            <a:r>
+              <a:rPr lang="en-US" dirty="0"/>
+              <a:t>Must </a:t>
+            </a:r>
+            <a:r>
+              <a:rPr lang="en-US" dirty="0" err="1"/>
+              <a:t>recognise</a:t>
+            </a:r>
+            <a:r>
+              <a:rPr lang="en-US" dirty="0"/>
+              <a:t> protocol extensions as a possibility.</a:t>
+            </a:r>
+          </a:p>
+          <a:p>
+            <a:pPr lvl="1">
+              <a:spcBef>
+                <a:spcPts val="0"/>
+              </a:spcBef>
+            </a:pPr>
+            <a:r>
+              <a:rPr lang="en-US" dirty="0"/>
+              <a:t>No need to say why we have fast notifications (we already know from the rest of the charter).</a:t>
+            </a:r>
+          </a:p>
+          <a:p>
+            <a:pPr lvl="1">
+              <a:spcBef>
+                <a:spcPts val="0"/>
+              </a:spcBef>
+            </a:pPr>
+            <a:r>
+              <a:rPr lang="en-US" dirty="0"/>
+              <a:t>Very important that any protocol extensions are handled in association with the WG that owns the protocol.</a:t>
+            </a:r>
+          </a:p>
+        </p:txBody>
+      </p:sp>
+    </p:spTree>
+    <p:extLst>
+      <p:ext uri="{BB962C8B-B14F-4D97-AF65-F5344CB8AC3E}">
+        <p14:creationId xmlns:p14="http://schemas.microsoft.com/office/powerpoint/2010/main" val="483566530"/>
+      </p:ext>
+    </p:extLst>
+  </p:cSld>
+  <p:clrMapOvr>
+    <a:masterClrMapping/>
+  </p:clrMapOvr>
+</p:sld>
+</file>
+
+<file path=ppt/slides/slide15.xml><?xml version="1.0" encoding="utf-8"?>
+<p:sld xmlns:a="http://schemas.openxmlformats.org/drawingml/2006/main" xmlns:r="http://schemas.openxmlformats.org/officeDocument/2006/relationships" xmlns:p="http://schemas.openxmlformats.org/presentationml/2006/main">
+  <p:cSld>
+    <p:spTree>
+      <p:nvGrpSpPr>
+        <p:cNvPr id="1" name="">
+          <a:extLst>
+            <a:ext uri="{FF2B5EF4-FFF2-40B4-BE49-F238E27FC236}">
+              <a16:creationId xmlns:a16="http://schemas.microsoft.com/office/drawing/2014/main" id="{F23A912E-6279-0822-F8D8-2DFC20DA39A7}"/>
+            </a:ext>
+          </a:extLst>
+        </p:cNvPr>
+        <p:cNvGrpSpPr/>
+        <p:nvPr/>
+      </p:nvGrpSpPr>
+      <p:grpSpPr>
+        <a:xfrm>
+          <a:off x="0" y="0"/>
+          <a:ext cx="0" cy="0"/>
+          <a:chOff x="0" y="0"/>
+          <a:chExt cx="0" cy="0"/>
+        </a:xfrm>
+      </p:grpSpPr>
+      <p:sp>
+        <p:nvSpPr>
+          <p:cNvPr id="2" name="Title 1">
+            <a:extLst>
+              <a:ext uri="{FF2B5EF4-FFF2-40B4-BE49-F238E27FC236}">
+                <a16:creationId xmlns:a16="http://schemas.microsoft.com/office/drawing/2014/main" id="{19A145A3-DCFD-6C85-1AF5-3D6D0E209622}"/>
+              </a:ext>
+            </a:extLst>
+          </p:cNvPr>
+          <p:cNvSpPr>
+            <a:spLocks noGrp="1"/>
+          </p:cNvSpPr>
+          <p:nvPr>
+            <p:ph type="title"/>
+          </p:nvPr>
+        </p:nvSpPr>
+        <p:spPr/>
+        <p:txBody>
+          <a:bodyPr/>
+          <a:lstStyle/>
+          <a:p>
+            <a:r>
+              <a:rPr lang="en-US" dirty="0"/>
+              <a:t>FANN charter text discussion</a:t>
+            </a:r>
+            <a:br>
+              <a:rPr lang="en-US" dirty="0"/>
+            </a:br>
+            <a:r>
+              <a:rPr lang="en-US" b="1" dirty="0"/>
+              <a:t>Open issues</a:t>
+            </a:r>
+            <a:endParaRPr lang="en-US" dirty="0"/>
+          </a:p>
+        </p:txBody>
+      </p:sp>
+      <p:sp>
+        <p:nvSpPr>
+          <p:cNvPr id="4" name="Slide Number Placeholder 3">
+            <a:extLst>
+              <a:ext uri="{FF2B5EF4-FFF2-40B4-BE49-F238E27FC236}">
+                <a16:creationId xmlns:a16="http://schemas.microsoft.com/office/drawing/2014/main" id="{711A951E-0DE9-26ED-803D-4B5010E17F75}"/>
+              </a:ext>
+            </a:extLst>
+          </p:cNvPr>
+          <p:cNvSpPr>
+            <a:spLocks noGrp="1"/>
+          </p:cNvSpPr>
+          <p:nvPr>
+            <p:ph type="sldNum" idx="12"/>
+          </p:nvPr>
+        </p:nvSpPr>
+        <p:spPr/>
+        <p:txBody>
+          <a:bodyPr/>
+          <a:lstStyle/>
+          <a:p>
+            <a:pPr marL="0" lvl="0" indent="0" algn="l" rtl="0">
+              <a:spcBef>
+                <a:spcPts val="0"/>
+              </a:spcBef>
+              <a:spcAft>
+                <a:spcPts val="0"/>
+              </a:spcAft>
+              <a:buNone/>
+            </a:pPr>
+            <a:fld id="{00000000-1234-1234-1234-123412341234}" type="slidenum">
+              <a:rPr lang="en-US" smtClean="0"/>
+              <a:t>15</a:t>
+            </a:fld>
+            <a:endParaRPr lang="en-US"/>
+          </a:p>
+        </p:txBody>
+      </p:sp>
+      <p:sp>
+        <p:nvSpPr>
+          <p:cNvPr id="6" name="Text Placeholder 5">
+            <a:extLst>
+              <a:ext uri="{FF2B5EF4-FFF2-40B4-BE49-F238E27FC236}">
+                <a16:creationId xmlns:a16="http://schemas.microsoft.com/office/drawing/2014/main" id="{F586499F-D2FB-5194-58F1-CB55FB50CA22}"/>
+              </a:ext>
+            </a:extLst>
+          </p:cNvPr>
+          <p:cNvSpPr>
+            <a:spLocks noGrp="1"/>
+          </p:cNvSpPr>
+          <p:nvPr>
+            <p:ph type="body" idx="1"/>
+          </p:nvPr>
+        </p:nvSpPr>
+        <p:spPr>
+          <a:xfrm>
+            <a:off x="538800" y="1802552"/>
+            <a:ext cx="8066400" cy="2710125"/>
+          </a:xfrm>
+        </p:spPr>
+        <p:txBody>
+          <a:bodyPr/>
+          <a:lstStyle/>
+          <a:p>
+            <a:r>
+              <a:rPr lang="en-US" sz="1600" dirty="0"/>
+              <a:t>Comments from </a:t>
+            </a:r>
+            <a:r>
+              <a:rPr lang="en-US" sz="1600" dirty="0" err="1"/>
+              <a:t>Yongqing</a:t>
+            </a:r>
+            <a:r>
+              <a:rPr lang="en-US" sz="1600" dirty="0"/>
+              <a:t> Zhu (</a:t>
+            </a:r>
+            <a:r>
+              <a:rPr lang="en-US" sz="1600" dirty="0">
+                <a:hlinkClick r:id="rId2"/>
+              </a:rPr>
+              <a:t>issue #30</a:t>
+            </a:r>
+            <a:r>
+              <a:rPr lang="en-US" sz="1600" dirty="0"/>
+              <a:t>)</a:t>
+            </a:r>
+          </a:p>
+          <a:p>
+            <a:pPr marL="939800" lvl="1" indent="-342900">
+              <a:spcBef>
+                <a:spcPts val="0"/>
+              </a:spcBef>
+              <a:buSzPct val="100000"/>
+              <a:buFont typeface="+mj-lt"/>
+              <a:buAutoNum type="arabicPeriod"/>
+            </a:pPr>
+            <a:r>
+              <a:rPr lang="en-US" sz="1200" dirty="0"/>
+              <a:t>Modern network applications, ranging from AI/ML training to cloud services, require adaptive networks to ensure reliable and congestion-free data transfer within or across multiple data centers.</a:t>
+            </a:r>
+          </a:p>
+          <a:p>
+            <a:pPr marL="1054100" lvl="2" indent="0">
+              <a:spcBef>
+                <a:spcPts val="0"/>
+              </a:spcBef>
+              <a:buNone/>
+            </a:pPr>
+            <a:r>
+              <a:rPr lang="en-US" sz="1200" dirty="0"/>
+              <a:t>[</a:t>
+            </a:r>
+            <a:r>
+              <a:rPr lang="en-US" sz="1200" dirty="0" err="1"/>
+              <a:t>Yongqing</a:t>
+            </a:r>
+            <a:r>
+              <a:rPr lang="en-US" sz="1200" dirty="0"/>
+              <a:t>] I think "require adaptive networks to ensure reliable, balanced, and congestion-free data transfer within or across multiple data centers." is better.</a:t>
+            </a:r>
+          </a:p>
+          <a:p>
+            <a:pPr marL="939800" lvl="1" indent="-342900">
+              <a:spcBef>
+                <a:spcPts val="0"/>
+              </a:spcBef>
+              <a:buSzPct val="100000"/>
+              <a:buFont typeface="+mj-lt"/>
+              <a:buAutoNum type="arabicPeriod"/>
+            </a:pPr>
+            <a:r>
+              <a:rPr lang="en-US" sz="1200" dirty="0"/>
+              <a:t>… to disseminate such information to relevant network nodes for their actions (e.g., traffic engineering (TE), load balancing, flow control, and protection switching etc.)</a:t>
+            </a:r>
+          </a:p>
+          <a:p>
+            <a:pPr marL="1054100" lvl="2" indent="0">
+              <a:spcBef>
+                <a:spcPts val="0"/>
+              </a:spcBef>
+              <a:buNone/>
+            </a:pPr>
+            <a:r>
+              <a:rPr lang="en-US" sz="1200" dirty="0"/>
+              <a:t>[</a:t>
+            </a:r>
+            <a:r>
+              <a:rPr lang="en-US" sz="1200" dirty="0" err="1"/>
+              <a:t>Yongqing</a:t>
+            </a:r>
+            <a:r>
+              <a:rPr lang="en-US" sz="1200" dirty="0"/>
+              <a:t>] Generally speaking (as described in RFC9522),  “load balancing, flow control, and protection switching” are major aspects of the TE. But sometimes, TE also refers to some specific technologies (e.g. SR-TE, MPLS-TE, etc.) which can compute a path based on the network status and/or service demand, and steer traffic along the path. If the "TE" you mentioned here is the former one, it’s better to be removed to avoid unnecessary repetition.</a:t>
+            </a:r>
+          </a:p>
+          <a:p>
+            <a:pPr marL="939800" lvl="1" indent="-342900">
+              <a:spcBef>
+                <a:spcPts val="0"/>
+              </a:spcBef>
+              <a:buFont typeface="+mj-lt"/>
+              <a:buAutoNum type="arabicPeriod"/>
+            </a:pPr>
+            <a:endParaRPr lang="en-US" sz="1200" dirty="0"/>
+          </a:p>
+        </p:txBody>
+      </p:sp>
+    </p:spTree>
+    <p:extLst>
+      <p:ext uri="{BB962C8B-B14F-4D97-AF65-F5344CB8AC3E}">
+        <p14:creationId xmlns:p14="http://schemas.microsoft.com/office/powerpoint/2010/main" val="770136323"/>
+      </p:ext>
+    </p:extLst>
+  </p:cSld>
+  <p:clrMapOvr>
+    <a:masterClrMapping/>
+  </p:clrMapOvr>
+</p:sld>
+</file>
+
+<file path=ppt/slides/slide16.xml><?xml version="1.0" encoding="utf-8"?>
+<p:sld xmlns:a="http://schemas.openxmlformats.org/drawingml/2006/main" xmlns:r="http://schemas.openxmlformats.org/officeDocument/2006/relationships" xmlns:p="http://schemas.openxmlformats.org/presentationml/2006/main">
+  <p:cSld>
+    <p:spTree>
+      <p:nvGrpSpPr>
+        <p:cNvPr id="1" name="">
+          <a:extLst>
+            <a:ext uri="{FF2B5EF4-FFF2-40B4-BE49-F238E27FC236}">
+              <a16:creationId xmlns:a16="http://schemas.microsoft.com/office/drawing/2014/main" id="{33AA4EB7-5CBF-BDEC-9E62-B2AFF0BCB28B}"/>
+            </a:ext>
+          </a:extLst>
+        </p:cNvPr>
+        <p:cNvGrpSpPr/>
+        <p:nvPr/>
+      </p:nvGrpSpPr>
+      <p:grpSpPr>
+        <a:xfrm>
+          <a:off x="0" y="0"/>
+          <a:ext cx="0" cy="0"/>
+          <a:chOff x="0" y="0"/>
+          <a:chExt cx="0" cy="0"/>
+        </a:xfrm>
+      </p:grpSpPr>
+      <p:sp>
+        <p:nvSpPr>
+          <p:cNvPr id="2" name="Title 1">
+            <a:extLst>
+              <a:ext uri="{FF2B5EF4-FFF2-40B4-BE49-F238E27FC236}">
+                <a16:creationId xmlns:a16="http://schemas.microsoft.com/office/drawing/2014/main" id="{C864BCD7-21BD-C6F2-8D15-267E2F7BB053}"/>
+              </a:ext>
+            </a:extLst>
+          </p:cNvPr>
+          <p:cNvSpPr>
+            <a:spLocks noGrp="1"/>
+          </p:cNvSpPr>
+          <p:nvPr>
+            <p:ph type="title"/>
+          </p:nvPr>
+        </p:nvSpPr>
+        <p:spPr/>
+        <p:txBody>
+          <a:bodyPr/>
+          <a:lstStyle/>
+          <a:p>
+            <a:r>
+              <a:rPr lang="en-US" dirty="0"/>
+              <a:t>FANN charter text discussion</a:t>
+            </a:r>
+            <a:br>
+              <a:rPr lang="en-US" dirty="0"/>
+            </a:br>
+            <a:r>
+              <a:rPr lang="en-US" b="1" dirty="0"/>
+              <a:t>Open issues</a:t>
+            </a:r>
+            <a:endParaRPr lang="en-US" dirty="0"/>
+          </a:p>
+        </p:txBody>
+      </p:sp>
+      <p:sp>
+        <p:nvSpPr>
+          <p:cNvPr id="4" name="Slide Number Placeholder 3">
+            <a:extLst>
+              <a:ext uri="{FF2B5EF4-FFF2-40B4-BE49-F238E27FC236}">
+                <a16:creationId xmlns:a16="http://schemas.microsoft.com/office/drawing/2014/main" id="{DB1679D5-FF4C-7386-B207-924F43D0E5C4}"/>
+              </a:ext>
+            </a:extLst>
+          </p:cNvPr>
+          <p:cNvSpPr>
+            <a:spLocks noGrp="1"/>
+          </p:cNvSpPr>
+          <p:nvPr>
+            <p:ph type="sldNum" idx="12"/>
+          </p:nvPr>
+        </p:nvSpPr>
+        <p:spPr/>
+        <p:txBody>
+          <a:bodyPr/>
+          <a:lstStyle/>
+          <a:p>
+            <a:pPr marL="0" lvl="0" indent="0" algn="l" rtl="0">
+              <a:spcBef>
+                <a:spcPts val="0"/>
+              </a:spcBef>
+              <a:spcAft>
+                <a:spcPts val="0"/>
+              </a:spcAft>
+              <a:buNone/>
+            </a:pPr>
+            <a:fld id="{00000000-1234-1234-1234-123412341234}" type="slidenum">
+              <a:rPr lang="en-US" smtClean="0"/>
+              <a:t>16</a:t>
+            </a:fld>
+            <a:endParaRPr lang="en-US"/>
+          </a:p>
+        </p:txBody>
+      </p:sp>
+      <p:sp>
+        <p:nvSpPr>
+          <p:cNvPr id="6" name="Text Placeholder 5">
+            <a:extLst>
+              <a:ext uri="{FF2B5EF4-FFF2-40B4-BE49-F238E27FC236}">
+                <a16:creationId xmlns:a16="http://schemas.microsoft.com/office/drawing/2014/main" id="{9F741E28-B0A5-5985-1EA3-25746AC53769}"/>
+              </a:ext>
+            </a:extLst>
+          </p:cNvPr>
+          <p:cNvSpPr>
+            <a:spLocks noGrp="1"/>
+          </p:cNvSpPr>
+          <p:nvPr>
+            <p:ph type="body" idx="1"/>
+          </p:nvPr>
+        </p:nvSpPr>
+        <p:spPr>
+          <a:xfrm>
+            <a:off x="538800" y="1802552"/>
+            <a:ext cx="8066400" cy="2710125"/>
+          </a:xfrm>
+        </p:spPr>
+        <p:txBody>
+          <a:bodyPr/>
+          <a:lstStyle/>
+          <a:p>
+            <a:r>
+              <a:rPr lang="en-US" sz="1600" dirty="0"/>
+              <a:t>Comments from </a:t>
+            </a:r>
+            <a:r>
+              <a:rPr lang="en-US" sz="1600" dirty="0" err="1"/>
+              <a:t>Yongqing</a:t>
+            </a:r>
+            <a:r>
+              <a:rPr lang="en-US" sz="1600" dirty="0"/>
+              <a:t> Zhu (</a:t>
+            </a:r>
+            <a:r>
+              <a:rPr lang="en-US" sz="1600" dirty="0">
+                <a:hlinkClick r:id="rId2"/>
+              </a:rPr>
+              <a:t>issue #30</a:t>
+            </a:r>
+            <a:r>
+              <a:rPr lang="en-US" sz="1600" dirty="0"/>
+              <a:t>)</a:t>
+            </a:r>
+          </a:p>
+          <a:p>
+            <a:pPr marL="939800" lvl="1" indent="-342900">
+              <a:spcBef>
+                <a:spcPts val="0"/>
+              </a:spcBef>
+              <a:buSzPct val="100000"/>
+              <a:buFont typeface="+mj-lt"/>
+              <a:buAutoNum type="arabicPeriod" startAt="3"/>
+            </a:pPr>
+            <a:r>
+              <a:rPr lang="en-US" sz="1200" dirty="0"/>
+              <a:t>It is considered that the protocols and mechanisms of fast network notifications can be applied to different data plane technologies in layer-3 (e.g. IPv4, IPv6, SRv6 and MPLS), and the mechanisms can be useful for the management of both the TE traffic and the traffic which takes the shortest paths.</a:t>
+            </a:r>
+          </a:p>
+          <a:p>
+            <a:pPr marL="1054100" lvl="2" indent="0">
+              <a:spcBef>
+                <a:spcPts val="0"/>
+              </a:spcBef>
+              <a:buNone/>
+            </a:pPr>
+            <a:r>
+              <a:rPr lang="en-US" sz="1200" dirty="0"/>
+              <a:t>[</a:t>
+            </a:r>
+            <a:r>
+              <a:rPr lang="en-US" sz="1200" dirty="0" err="1"/>
+              <a:t>Yongqing</a:t>
+            </a:r>
+            <a:r>
+              <a:rPr lang="en-US" sz="1200" dirty="0"/>
+              <a:t>] MPLS is not a L3 technology. If we want to emphasize the phrase “Layer-3”, then MPLS should be removed here; otherwise, the data plan technology should not be confined to L3.</a:t>
+            </a:r>
+          </a:p>
+          <a:p>
+            <a:pPr marL="939800" lvl="1" indent="-342900">
+              <a:spcBef>
+                <a:spcPts val="0"/>
+              </a:spcBef>
+              <a:buFont typeface="+mj-lt"/>
+              <a:buAutoNum type="arabicPeriod" startAt="3"/>
+            </a:pPr>
+            <a:r>
+              <a:rPr lang="en-US" sz="1200" dirty="0"/>
+              <a:t>#Work items / Requirements and Gap Analysis / o For each use case, describe the requirements on the information needed, the time scale of the notification, and the actions to be </a:t>
+            </a:r>
+            <a:r>
+              <a:rPr lang="en-US" sz="1200" dirty="0" err="1"/>
+              <a:t>peformed</a:t>
+            </a:r>
+            <a:r>
+              <a:rPr lang="en-US" sz="1200" dirty="0"/>
+              <a:t>.</a:t>
+            </a:r>
+          </a:p>
+          <a:p>
+            <a:pPr marL="1054100" lvl="2" indent="0">
+              <a:spcBef>
+                <a:spcPts val="0"/>
+              </a:spcBef>
+              <a:buNone/>
+            </a:pPr>
+            <a:r>
+              <a:rPr lang="en-US" sz="1200" dirty="0"/>
+              <a:t>[</a:t>
+            </a:r>
+            <a:r>
+              <a:rPr lang="en-US" sz="1200" dirty="0" err="1"/>
+              <a:t>Yongqing</a:t>
+            </a:r>
+            <a:r>
+              <a:rPr lang="en-US" sz="1200" dirty="0"/>
+              <a:t>] Maybe the information scope (i.e., which nodes should receive the notification), should be added here.</a:t>
+            </a:r>
+          </a:p>
+        </p:txBody>
+      </p:sp>
+    </p:spTree>
+    <p:extLst>
+      <p:ext uri="{BB962C8B-B14F-4D97-AF65-F5344CB8AC3E}">
+        <p14:creationId xmlns:p14="http://schemas.microsoft.com/office/powerpoint/2010/main" val="2500164070"/>
+      </p:ext>
+    </p:extLst>
+  </p:cSld>
+  <p:clrMapOvr>
+    <a:masterClrMapping/>
+  </p:clrMapOvr>
+</p:sld>
+</file>
+
+<file path=ppt/slides/slide17.xml><?xml version="1.0" encoding="utf-8"?>
+<p:sld xmlns:a="http://schemas.openxmlformats.org/drawingml/2006/main" xmlns:r="http://schemas.openxmlformats.org/officeDocument/2006/relationships" xmlns:p="http://schemas.openxmlformats.org/presentationml/2006/main">
+  <p:cSld>
+    <p:spTree>
+      <p:nvGrpSpPr>
+        <p:cNvPr id="1" name="">
+          <a:extLst>
+            <a:ext uri="{FF2B5EF4-FFF2-40B4-BE49-F238E27FC236}">
+              <a16:creationId xmlns:a16="http://schemas.microsoft.com/office/drawing/2014/main" id="{6EAAD161-3044-4AE3-51DE-44AE13E3F089}"/>
+            </a:ext>
+          </a:extLst>
+        </p:cNvPr>
+        <p:cNvGrpSpPr/>
+        <p:nvPr/>
+      </p:nvGrpSpPr>
+      <p:grpSpPr>
+        <a:xfrm>
+          <a:off x="0" y="0"/>
+          <a:ext cx="0" cy="0"/>
+          <a:chOff x="0" y="0"/>
+          <a:chExt cx="0" cy="0"/>
+        </a:xfrm>
+      </p:grpSpPr>
+      <p:sp>
+        <p:nvSpPr>
+          <p:cNvPr id="2" name="Title 1">
+            <a:extLst>
+              <a:ext uri="{FF2B5EF4-FFF2-40B4-BE49-F238E27FC236}">
+                <a16:creationId xmlns:a16="http://schemas.microsoft.com/office/drawing/2014/main" id="{A3E04446-F2BA-C94B-150F-53794BF8A277}"/>
+              </a:ext>
+            </a:extLst>
+          </p:cNvPr>
+          <p:cNvSpPr>
+            <a:spLocks noGrp="1"/>
+          </p:cNvSpPr>
+          <p:nvPr>
+            <p:ph type="title"/>
+          </p:nvPr>
+        </p:nvSpPr>
+        <p:spPr/>
+        <p:txBody>
+          <a:bodyPr/>
+          <a:lstStyle/>
+          <a:p>
+            <a:r>
+              <a:rPr lang="en-US" dirty="0"/>
+              <a:t>FANN charter text discussion</a:t>
+            </a:r>
+            <a:br>
+              <a:rPr lang="en-US" dirty="0"/>
+            </a:br>
+            <a:r>
+              <a:rPr lang="en-US" b="1" dirty="0"/>
+              <a:t>Open issues</a:t>
+            </a:r>
+            <a:endParaRPr lang="en-US" dirty="0"/>
+          </a:p>
+        </p:txBody>
+      </p:sp>
+      <p:sp>
+        <p:nvSpPr>
+          <p:cNvPr id="4" name="Slide Number Placeholder 3">
+            <a:extLst>
+              <a:ext uri="{FF2B5EF4-FFF2-40B4-BE49-F238E27FC236}">
+                <a16:creationId xmlns:a16="http://schemas.microsoft.com/office/drawing/2014/main" id="{2C63AD6F-6209-70E9-AA74-FB50560FF346}"/>
+              </a:ext>
+            </a:extLst>
+          </p:cNvPr>
+          <p:cNvSpPr>
+            <a:spLocks noGrp="1"/>
+          </p:cNvSpPr>
+          <p:nvPr>
+            <p:ph type="sldNum" idx="12"/>
+          </p:nvPr>
+        </p:nvSpPr>
+        <p:spPr/>
+        <p:txBody>
+          <a:bodyPr/>
+          <a:lstStyle/>
+          <a:p>
+            <a:pPr marL="0" lvl="0" indent="0" algn="l" rtl="0">
+              <a:spcBef>
+                <a:spcPts val="0"/>
+              </a:spcBef>
+              <a:spcAft>
+                <a:spcPts val="0"/>
+              </a:spcAft>
+              <a:buNone/>
+            </a:pPr>
+            <a:fld id="{00000000-1234-1234-1234-123412341234}" type="slidenum">
+              <a:rPr lang="en-US" smtClean="0"/>
+              <a:t>17</a:t>
+            </a:fld>
+            <a:endParaRPr lang="en-US"/>
+          </a:p>
+        </p:txBody>
+      </p:sp>
+      <p:sp>
+        <p:nvSpPr>
+          <p:cNvPr id="6" name="Text Placeholder 5">
+            <a:extLst>
+              <a:ext uri="{FF2B5EF4-FFF2-40B4-BE49-F238E27FC236}">
+                <a16:creationId xmlns:a16="http://schemas.microsoft.com/office/drawing/2014/main" id="{A9738FB6-F880-F9F5-67A9-E40BF01A415E}"/>
+              </a:ext>
+            </a:extLst>
+          </p:cNvPr>
+          <p:cNvSpPr>
+            <a:spLocks noGrp="1"/>
+          </p:cNvSpPr>
+          <p:nvPr>
+            <p:ph type="body" idx="1"/>
+          </p:nvPr>
+        </p:nvSpPr>
+        <p:spPr>
+          <a:xfrm>
+            <a:off x="538800" y="1802552"/>
+            <a:ext cx="8066400" cy="2710125"/>
+          </a:xfrm>
+        </p:spPr>
+        <p:txBody>
+          <a:bodyPr/>
+          <a:lstStyle/>
+          <a:p>
+            <a:r>
+              <a:rPr lang="en-US" sz="1600" dirty="0"/>
+              <a:t>Comments from </a:t>
+            </a:r>
+            <a:r>
+              <a:rPr lang="en-US" sz="1600" dirty="0" err="1"/>
+              <a:t>Yongqing</a:t>
+            </a:r>
+            <a:r>
+              <a:rPr lang="en-US" sz="1600" dirty="0"/>
+              <a:t> Zhu (</a:t>
+            </a:r>
+            <a:r>
+              <a:rPr lang="en-US" sz="1600" dirty="0">
+                <a:hlinkClick r:id="rId2"/>
+              </a:rPr>
+              <a:t>issue #30</a:t>
+            </a:r>
+            <a:r>
+              <a:rPr lang="en-US" sz="1600" dirty="0"/>
+              <a:t>)</a:t>
+            </a:r>
+            <a:endParaRPr lang="en-US" sz="1200" dirty="0"/>
+          </a:p>
+          <a:p>
+            <a:pPr marL="939800" lvl="1" indent="-342900">
+              <a:spcBef>
+                <a:spcPts val="0"/>
+              </a:spcBef>
+              <a:buSzPct val="100000"/>
+              <a:buFont typeface="+mj-lt"/>
+              <a:buAutoNum type="arabicPeriod" startAt="5"/>
+            </a:pPr>
+            <a:r>
+              <a:rPr lang="en-US" sz="1200" dirty="0"/>
+              <a:t># Work items / Define an Information Model of fast network notifications / Develop an Information Model that structures real-time network condition data in a standardized way for effective dissemination and actions / o Define the requirements of the data needed for functions/actions including but not limited to traffic engineering, load balancing, flow control and protection switching.</a:t>
+            </a:r>
+          </a:p>
+          <a:p>
+            <a:pPr marL="1054100" lvl="2" indent="0">
+              <a:spcBef>
+                <a:spcPts val="0"/>
+              </a:spcBef>
+              <a:buNone/>
+            </a:pPr>
+            <a:r>
+              <a:rPr lang="en-US" sz="1200" dirty="0"/>
+              <a:t>[</a:t>
+            </a:r>
+            <a:r>
+              <a:rPr lang="en-US" sz="1200" dirty="0" err="1"/>
+              <a:t>Yongqing</a:t>
+            </a:r>
+            <a:r>
+              <a:rPr lang="en-US" sz="1200" dirty="0"/>
+              <a:t>] Besides the following contents, we might need to define the abstraction about senders and receivers for information model.</a:t>
+            </a:r>
+          </a:p>
+        </p:txBody>
+      </p:sp>
+    </p:spTree>
+    <p:extLst>
+      <p:ext uri="{BB962C8B-B14F-4D97-AF65-F5344CB8AC3E}">
+        <p14:creationId xmlns:p14="http://schemas.microsoft.com/office/powerpoint/2010/main" val="945296299"/>
+      </p:ext>
+    </p:extLst>
+  </p:cSld>
+  <p:clrMapOvr>
+    <a:masterClrMapping/>
+  </p:clrMapOvr>
+</p:sld>
+</file>
+
+<file path=ppt/slides/slide18.xml><?xml version="1.0" encoding="utf-8"?>
+<p:sld xmlns:a="http://schemas.openxmlformats.org/drawingml/2006/main" xmlns:r="http://schemas.openxmlformats.org/officeDocument/2006/relationships" xmlns:p="http://schemas.openxmlformats.org/presentationml/2006/main">
+  <p:cSld>
+    <p:spTree>
+      <p:nvGrpSpPr>
+        <p:cNvPr id="1" name="">
+          <a:extLst>
+            <a:ext uri="{FF2B5EF4-FFF2-40B4-BE49-F238E27FC236}">
               <a16:creationId xmlns:a16="http://schemas.microsoft.com/office/drawing/2014/main" id="{0CC670B1-77A7-74E1-58C1-E1CCA0B4585D}"/>
             </a:ext>
           </a:extLst>
@@ -16910,7 +18748,7 @@
             </a:pPr>
             <a:fld id="{00000000-1234-1234-1234-123412341234}" type="slidenum">
               <a:rPr lang="en-US" smtClean="0"/>
-              <a:t>10</a:t>
+              <a:t>18</a:t>
             </a:fld>
             <a:endParaRPr lang="en-US"/>
           </a:p>
@@ -16937,7 +18775,23 @@
           <a:bodyPr/>
           <a:lstStyle/>
           <a:p>
-            <a:endParaRPr lang="en-US"/>
+            <a:r>
+              <a:rPr lang="en-US" sz="2400" dirty="0"/>
+              <a:t>Update the charter based on comments</a:t>
+            </a:r>
+          </a:p>
+          <a:p>
+            <a:pPr lvl="1"/>
+            <a:r>
+              <a:rPr lang="en-US" sz="1800" dirty="0"/>
+              <a:t>If you have additional comments, send it to the mailing list</a:t>
+            </a:r>
+          </a:p>
+          <a:p>
+            <a:pPr marL="114300" indent="0">
+              <a:buNone/>
+            </a:pPr>
+            <a:endParaRPr lang="en-US" sz="2400" dirty="0"/>
           </a:p>
         </p:txBody>
       </p:sp>
@@ -17692,7 +19546,7 @@
         <p:fade/>
       </p:transition>
     </mc:Choice>
-    <mc:Fallback xmlns:ahyp="http://schemas.microsoft.com/office/drawing/2018/hyperlinkcolor" xmlns:p15="http://schemas.microsoft.com/office/powerpoint/2012/main" xmlns:com="http://schemas.openxmlformats.org/drawingml/2006/compatibility" xmlns:pvml="urn:schemas-microsoft-com:office:powerpoint" xmlns:v="urn:schemas-microsoft-com:vml" xmlns:o="urn:schemas-microsoft-com:office:office" xmlns:dgm="http://schemas.openxmlformats.org/drawingml/2006/diagram" xmlns:c="http://schemas.openxmlformats.org/drawingml/2006/chart" xmlns:mv="urn:schemas-microsoft-com:mac:vml" xmlns="">
+    <mc:Fallback xmlns="" xmlns:mv="urn:schemas-microsoft-com:mac:vml" xmlns:c="http://schemas.openxmlformats.org/drawingml/2006/chart" xmlns:dgm="http://schemas.openxmlformats.org/drawingml/2006/diagram" xmlns:o="urn:schemas-microsoft-com:office:office" xmlns:v="urn:schemas-microsoft-com:vml" xmlns:pvml="urn:schemas-microsoft-com:office:powerpoint" xmlns:com="http://schemas.openxmlformats.org/drawingml/2006/compatibility" xmlns:p15="http://schemas.microsoft.com/office/powerpoint/2012/main" xmlns:ahyp="http://schemas.microsoft.com/office/drawing/2018/hyperlinkcolor">
       <p:transition spd="slow">
         <p:fade/>
       </p:transition>
@@ -17779,6 +19633,28 @@
             <a:r>
               <a:rPr lang="en-US" dirty="0"/>
               <a:t>FANN charter text discussion</a:t>
+            </a:r>
+          </a:p>
+          <a:p>
+            <a:pPr lvl="1">
+              <a:spcBef>
+                <a:spcPts val="600"/>
+              </a:spcBef>
+            </a:pPr>
+            <a:r>
+              <a:rPr lang="en-US" dirty="0"/>
+              <a:t>Base text</a:t>
+            </a:r>
+          </a:p>
+          <a:p>
+            <a:pPr lvl="1">
+              <a:spcBef>
+                <a:spcPts val="600"/>
+              </a:spcBef>
+            </a:pPr>
+            <a:r>
+              <a:rPr lang="en-US" dirty="0"/>
+              <a:t>Open issues</a:t>
             </a:r>
           </a:p>
           <a:p>
@@ -18115,8 +19991,12 @@
               <a:rPr lang="en-US" dirty="0"/>
             </a:br>
             <a:r>
+              <a:rPr lang="en-US" b="1" dirty="0"/>
+              <a:t>Overview</a:t>
+            </a:r>
+            <a:r>
               <a:rPr lang="en-US" dirty="0"/>
-              <a:t>Overview </a:t>
+              <a:t> </a:t>
             </a:r>
           </a:p>
         </p:txBody>
@@ -18137,7 +20017,12 @@
             <p:ph type="body" idx="1"/>
           </p:nvPr>
         </p:nvSpPr>
-        <p:spPr/>
+        <p:spPr>
+          <a:xfrm>
+            <a:off x="627500" y="1794600"/>
+            <a:ext cx="7845940" cy="3204120"/>
+          </a:xfrm>
+        </p:spPr>
         <p:txBody>
           <a:bodyPr/>
           <a:lstStyle/>
@@ -18147,7 +20032,15 @@
             </a:pPr>
             <a:r>
               <a:rPr lang="en-US" sz="1100" dirty="0"/>
-              <a:t>Modern network applications, ranging from AI/ML training to cloud services, require adaptive networks to ensure reliable and congestion-free data transfer within or across multiple data centers. However, existing traffic management mechanisms often face limitations in responsiveness, coverage, and operational complexity, particularly in high-speed, large-scale, dynamic network environments.</a:t>
+              <a:t>Modern network applications, ranging from AI/ML training to cloud services, require adaptive networks to ensure reliable and congestion-free data transfer within or across multiple data centers. However, </a:t>
+            </a:r>
+            <a:r>
+              <a:rPr lang="en-US" sz="1100" b="1" dirty="0"/>
+              <a:t>existing traffic management mechanisms often face limitations in responsiveness, </a:t>
+            </a:r>
+            <a:r>
+              <a:rPr lang="en-US" sz="1100" dirty="0"/>
+              <a:t>coverage, and operational complexity, particularly in high-speed, large-scale, dynamic network environments: these limitations are caused by issues around the mechanisms used to disseminate and correlate network state information.</a:t>
             </a:r>
           </a:p>
           <a:p>
@@ -18161,8 +20054,28 @@
               <a:buNone/>
             </a:pPr>
             <a:r>
+              <a:rPr lang="en-US" sz="1100" b="1" dirty="0"/>
+              <a:t>Modern network hardware is capable of detecting congestion</a:t>
+            </a:r>
+            <a:r>
               <a:rPr lang="en-US" sz="1100" dirty="0"/>
-              <a:t>Modern network hardware is capable of detecting congestion, microbursts and other local status at fine-grained time scales (ranging from microseconds to sub-millisecond), which outpaces the time needed for current mechanisms (e.g. control plane based information distribution or management plane based information collection） to disseminate such information to relevant network nodes for their actions (e.g., traffic engineering (TE), load balancing, flow control, and protection switching etc.), leading to suboptimal performance, delayed recovery, congestion, and inefficient resource utilization.</a:t>
+              <a:t>, microbursts and other local statuses </a:t>
+            </a:r>
+            <a:r>
+              <a:rPr lang="en-US" sz="1100" b="1" dirty="0"/>
+              <a:t>at fine-grained time scales</a:t>
+            </a:r>
+            <a:r>
+              <a:rPr lang="en-US" sz="1100" dirty="0"/>
+              <a:t> (ranging from microseconds to sub-millisecond), which </a:t>
+            </a:r>
+            <a:r>
+              <a:rPr lang="en-US" sz="1100" b="1" dirty="0"/>
+              <a:t>outpaces the time needed for current mechanisms</a:t>
+            </a:r>
+            <a:r>
+              <a:rPr lang="en-US" sz="1100" dirty="0"/>
+              <a:t> (e.g. control plane based information distribution or management plane based information collection to disseminate such information to relevant network nodes for their actions (e.g., traffic engineering (TE), load balancing, flow control, and protection switching etc.), leading to suboptimal performance, delayed recovery, congestion, and inefficient resource utilization.</a:t>
             </a:r>
           </a:p>
           <a:p>
@@ -18185,7 +20098,23 @@
             </a:r>
             <a:r>
               <a:rPr lang="en-US" sz="1100" dirty="0"/>
-              <a:t> Network Notification (FANN) Working Group is chartered to specify the protocols, mechanisms, and procedures for on-demand, fast notifications of fine-grained network status information, which allow network nodes that may take response actions to learn quickly about the network conditions.</a:t>
+              <a:t> Network Notification (</a:t>
+            </a:r>
+            <a:r>
+              <a:rPr lang="en-US" sz="1100" b="1" dirty="0"/>
+              <a:t>FANN</a:t>
+            </a:r>
+            <a:r>
+              <a:rPr lang="en-US" sz="1100" dirty="0"/>
+              <a:t>) Working Group is chartered to </a:t>
+            </a:r>
+            <a:r>
+              <a:rPr lang="en-US" sz="1100" b="1" dirty="0"/>
+              <a:t>specify the protocols, mechanisms, and procedures for on-demand, fast notification of fine-grained network status information</a:t>
+            </a:r>
+            <a:r>
+              <a:rPr lang="en-US" sz="1100" dirty="0"/>
+              <a:t>, which allow network nodes that may take response actions to learn quickly about network conditions.</a:t>
             </a:r>
           </a:p>
         </p:txBody>
@@ -18293,8 +20222,12 @@
               <a:rPr lang="en-US" dirty="0"/>
             </a:br>
             <a:r>
+              <a:rPr lang="en-US" b="1" dirty="0"/>
+              <a:t>Scope</a:t>
+            </a:r>
+            <a:r>
               <a:rPr lang="en-US" dirty="0"/>
-              <a:t>Scope </a:t>
+              <a:t> </a:t>
             </a:r>
           </a:p>
         </p:txBody>
@@ -18315,7 +20248,12 @@
             <p:ph type="body" idx="1"/>
           </p:nvPr>
         </p:nvSpPr>
-        <p:spPr/>
+        <p:spPr>
+          <a:xfrm>
+            <a:off x="627500" y="1794600"/>
+            <a:ext cx="7868800" cy="2710125"/>
+          </a:xfrm>
+        </p:spPr>
         <p:txBody>
           <a:bodyPr/>
           <a:lstStyle/>
@@ -18325,7 +20263,23 @@
             </a:pPr>
             <a:r>
               <a:rPr lang="en-US" sz="1050" dirty="0"/>
-              <a:t>The network condition data that may be advertised using fast network notifications includes link failure, link congestion, SLA violations, and queue build-up etc. An information model may be defined to structure the network condition data in a standardized way for effective dissemination and actions.</a:t>
+              <a:t>The network condition data that may be advertised using </a:t>
+            </a:r>
+            <a:r>
+              <a:rPr lang="en-US" sz="1050" b="1" dirty="0"/>
+              <a:t>fast network notifications includes link failures, link congestion, SLA violations, and queue build-up etc</a:t>
+            </a:r>
+            <a:r>
+              <a:rPr lang="en-US" sz="1050" dirty="0"/>
+              <a:t>. An </a:t>
+            </a:r>
+            <a:r>
+              <a:rPr lang="en-US" sz="1050" b="1" dirty="0"/>
+              <a:t>information model will be defined</a:t>
+            </a:r>
+            <a:r>
+              <a:rPr lang="en-US" sz="1050" dirty="0"/>
+              <a:t> to structure the network condition data in a standardized way for effective dissemination and actions.</a:t>
             </a:r>
           </a:p>
           <a:p>
@@ -18340,7 +20294,11 @@
             </a:pPr>
             <a:r>
               <a:rPr lang="en-US" sz="1050" dirty="0"/>
-              <a:t>The fast network notifications may be used in network scenarios including Data Center Networks (DCN) and Wide Area Networks (WAN) which provide inter-connection between multiple data centers. The specific protocols and mechanisms may be different to meet the requirements in different network scenarios.</a:t>
+              <a:t>The fast network notifications may be used in network scenarios including Data Center Networks (DCN) and Wide Area Networks (WAN) which provide inter-connection between multiple data centers. The </a:t>
+            </a:r>
+            <a:r>
+              <a:rPr lang="en-US" sz="1050" b="1" dirty="0"/>
+              <a:t>specific protocols and mechanisms may be different to meet the requirements in different network scenarios.</a:t>
             </a:r>
           </a:p>
           <a:p>
@@ -18355,7 +20313,23 @@
             </a:pPr>
             <a:r>
               <a:rPr lang="en-US" sz="1050" dirty="0"/>
-              <a:t>It is considered that the protocols and mechanisms of fast network notifications can be applied to different data plane technologies in layer-3 (e.g. IPv4, IPv6, SRv6 and MPLS), and the mechanisms can be useful for the management of both the TE traffic and the traffic which takes the shortest paths. </a:t>
+              <a:t>The </a:t>
+            </a:r>
+            <a:r>
+              <a:rPr lang="en-US" sz="1050" b="1" dirty="0"/>
+              <a:t>protocols and mechanisms </a:t>
+            </a:r>
+            <a:r>
+              <a:rPr lang="en-US" sz="1050" dirty="0"/>
+              <a:t>developed by FANN for fast network notification </a:t>
+            </a:r>
+            <a:r>
+              <a:rPr lang="en-US" sz="1050" b="1" dirty="0"/>
+              <a:t>should be equally applicable to different IETF layer-3 data plane technologies</a:t>
+            </a:r>
+            <a:r>
+              <a:rPr lang="en-US" sz="1050" dirty="0"/>
+              <a:t> (i.e. IPv4, IPv6, SRv6 and MPLS), and should be useful for the management of both TE traffic and shortest-path / best effort traffic. </a:t>
             </a:r>
           </a:p>
           <a:p>
@@ -18370,7 +20344,23 @@
             </a:pPr>
             <a:r>
               <a:rPr lang="en-US" sz="1050" dirty="0"/>
-              <a:t>The FANN WG will identify the threat models for fast network notifications, and will address the security considerations introduced by the protocols it define. </a:t>
+              <a:t>The FANN WG will identify the </a:t>
+            </a:r>
+            <a:r>
+              <a:rPr lang="en-US" sz="1050" b="1" dirty="0"/>
+              <a:t>threat models for fast network notifications,</a:t>
+            </a:r>
+            <a:r>
+              <a:rPr lang="en-US" sz="1050" dirty="0"/>
+              <a:t> and will </a:t>
+            </a:r>
+            <a:r>
+              <a:rPr lang="en-US" sz="1050" b="1" dirty="0"/>
+              <a:t>address the security considerations</a:t>
+            </a:r>
+            <a:r>
+              <a:rPr lang="en-US" sz="1050" dirty="0"/>
+              <a:t> introduced by the protocols it defines. </a:t>
             </a:r>
           </a:p>
           <a:p>
@@ -18385,7 +20375,27 @@
             </a:pPr>
             <a:r>
               <a:rPr lang="en-US" sz="1050" dirty="0"/>
-              <a:t>The mechanisms for detecting network condition changes and the specific mechanisms for acting upon receiving the fast notifications are out of scope.</a:t>
+              <a:t>The </a:t>
+            </a:r>
+            <a:r>
+              <a:rPr lang="en-US" sz="1050" b="1" dirty="0"/>
+              <a:t>mechanisms for detecting network condition changes</a:t>
+            </a:r>
+            <a:r>
+              <a:rPr lang="en-US" sz="1050" dirty="0"/>
+              <a:t> and the specific </a:t>
+            </a:r>
+            <a:r>
+              <a:rPr lang="en-US" sz="1050" b="1" dirty="0"/>
+              <a:t>mechanisms for acting</a:t>
+            </a:r>
+            <a:r>
+              <a:rPr lang="en-US" sz="1050" dirty="0"/>
+              <a:t> upon received fast notifications are </a:t>
+            </a:r>
+            <a:r>
+              <a:rPr lang="en-US" sz="1050" b="1" dirty="0"/>
+              <a:t>out of scope. </a:t>
             </a:r>
           </a:p>
         </p:txBody>
@@ -18493,8 +20503,12 @@
               <a:rPr lang="en-US" dirty="0"/>
             </a:br>
             <a:r>
+              <a:rPr lang="en-US" b="1" dirty="0"/>
+              <a:t>Work Items</a:t>
+            </a:r>
+            <a:r>
               <a:rPr lang="en-US" dirty="0"/>
-              <a:t>Work Items </a:t>
+              <a:t> </a:t>
             </a:r>
           </a:p>
         </p:txBody>
@@ -18538,7 +20552,7 @@
               <a:buSzPct val="100000"/>
             </a:pPr>
             <a:r>
-              <a:rPr lang="en-US" sz="1000" dirty="0"/>
+              <a:rPr lang="en-US" sz="1000" b="1" dirty="0"/>
               <a:t>Requirements and Gap Analysis</a:t>
             </a:r>
           </a:p>
@@ -18575,7 +20589,7 @@
             </a:pPr>
             <a:r>
               <a:rPr lang="en-US" sz="1000" dirty="0"/>
-              <a:t>For each use case, describe the requirements on the information needed, the time scale of the notification, and the actions to be performed.</a:t>
+              <a:t>For each use case, describe the requirements on the information needed, the time scale of the notification, and the actions to be performed. </a:t>
             </a:r>
           </a:p>
           <a:p>
@@ -18587,7 +20601,7 @@
             </a:pPr>
             <a:r>
               <a:rPr lang="en-US" sz="1000" dirty="0"/>
-              <a:t>Identify the gaps for fast network notification mechanisms.  </a:t>
+              <a:t>Identify the gaps for fast network notification mechanisms.   </a:t>
             </a:r>
           </a:p>
           <a:p>
@@ -18596,7 +20610,11 @@
             </a:pPr>
             <a:r>
               <a:rPr lang="en-US" sz="1000" dirty="0"/>
-              <a:t>Define an Information Model of fast network notifications</a:t>
+              <a:t>Define an </a:t>
+            </a:r>
+            <a:r>
+              <a:rPr lang="en-US" sz="1000" b="1" dirty="0"/>
+              <a:t>Information Model of fast network notifications</a:t>
             </a:r>
           </a:p>
           <a:p>
@@ -18608,7 +20626,7 @@
             </a:pPr>
             <a:r>
               <a:rPr lang="en-US" sz="1000" dirty="0"/>
-              <a:t>Develop an Information Model that structures real-time network condition data in a standardized way for effective dissemination and actions.</a:t>
+              <a:t>Develop an Information Model that structures real-time network condition data in a standardized way for effective encoding in dissemination mechanisms and for efficient use by elements that take resultant actions.</a:t>
             </a:r>
           </a:p>
           <a:p>
@@ -18620,7 +20638,7 @@
             </a:pPr>
             <a:r>
               <a:rPr lang="en-US" sz="1000" dirty="0"/>
-              <a:t>Define the requirements of the data needed for functions/actions including but not limited to traffic engineering, load balancing, flow control and protection switching.</a:t>
+              <a:t>Define the requirements of the data needed for functions/actions including, but not limited to, traffic engineering, load balancing, flow control and protection switching.</a:t>
             </a:r>
           </a:p>
           <a:p>
@@ -18629,7 +20647,15 @@
             </a:pPr>
             <a:r>
               <a:rPr lang="en-US" sz="1000" dirty="0"/>
-              <a:t>Develop Fast Network Notification protocols and the related mechanisms</a:t>
+              <a:t>Develop </a:t>
+            </a:r>
+            <a:r>
+              <a:rPr lang="en-US" sz="1000" b="1" dirty="0"/>
+              <a:t>Fast Network Notification protocols</a:t>
+            </a:r>
+            <a:r>
+              <a:rPr lang="en-US" sz="1000" dirty="0"/>
+              <a:t> and the related mechanisms</a:t>
             </a:r>
           </a:p>
           <a:p>
@@ -18641,14 +20667,8 @@
             </a:pPr>
             <a:r>
               <a:rPr lang="en-US" sz="1000" dirty="0"/>
-              <a:t>Specify the fast network notification protocols and mechanisms that allow network nodes that may take response actions to learn quickly about network conditions. Different protocols may be defined to meet the requirements in different network scenarios. </a:t>
-            </a:r>
-          </a:p>
-          <a:p>
-            <a:pPr marL="114300" indent="0">
-              <a:buNone/>
-            </a:pPr>
-            <a:endParaRPr lang="en-US" sz="1000" dirty="0"/>
+              <a:t>Specify the fast network notification protocols and mechanisms that allow network nodes that may take response actions to learn quickly about network conditions. Different protocols may be defined to meet the requirements in different network scenarios.</a:t>
+            </a:r>
           </a:p>
           <a:p>
             <a:pPr marL="114300" indent="0">
@@ -18761,8 +20781,12 @@
               <a:rPr lang="en-US" dirty="0"/>
             </a:br>
             <a:r>
+              <a:rPr lang="en-US" b="1" dirty="0"/>
+              <a:t>Collaborations</a:t>
+            </a:r>
+            <a:r>
               <a:rPr lang="en-US" dirty="0"/>
-              <a:t>Collaborations </a:t>
+              <a:t> </a:t>
             </a:r>
           </a:p>
         </p:txBody>
@@ -18792,8 +20816,40 @@
               <a:buNone/>
             </a:pPr>
             <a:r>
-              <a:rPr lang="en-US" sz="1050" dirty="0"/>
-              <a:t>The FANN WG will collaborate closely with the TEAS WG to define the data needed for actions of traffic engineering mechanisms. It will collaborate with RTGWG for actions of Fast Reroute (FRR) and other protection mechanisms. It may collaborate with IDR and LSR WGs for the data needed by BGP and the IGPs. As needed, the WG will also coordinate with other relevant groups to communicate potential needs related to detection and data collection.</a:t>
+              <a:rPr lang="en-US" sz="1600" dirty="0"/>
+              <a:t>The FANN WG will collaborate closely with the </a:t>
+            </a:r>
+            <a:r>
+              <a:rPr lang="en-US" sz="1600" b="1" dirty="0"/>
+              <a:t>TEAS</a:t>
+            </a:r>
+            <a:r>
+              <a:rPr lang="en-US" sz="1600" dirty="0"/>
+              <a:t> WG to define the data needed for actions of traffic engineering mechanisms. It will collaborate with </a:t>
+            </a:r>
+            <a:r>
+              <a:rPr lang="en-US" sz="1600" b="1" dirty="0"/>
+              <a:t>RTGWG</a:t>
+            </a:r>
+            <a:r>
+              <a:rPr lang="en-US" sz="1600" dirty="0"/>
+              <a:t> for actions of Fast Reroute (FRR) and other protection mechanisms. It may collaborate with </a:t>
+            </a:r>
+            <a:r>
+              <a:rPr lang="en-US" sz="1600" b="1" dirty="0"/>
+              <a:t>IDR</a:t>
+            </a:r>
+            <a:r>
+              <a:rPr lang="en-US" sz="1600" dirty="0"/>
+              <a:t> and </a:t>
+            </a:r>
+            <a:r>
+              <a:rPr lang="en-US" sz="1600" b="1" dirty="0"/>
+              <a:t>LSR</a:t>
+            </a:r>
+            <a:r>
+              <a:rPr lang="en-US" sz="1600" dirty="0"/>
+              <a:t> WGs for the data needed by BGP and the IGPs. As needed, the WG will also coordinate with other relevant groups to communicate potential needs related to detection and data collection.</a:t>
             </a:r>
           </a:p>
         </p:txBody>
@@ -18857,7 +20913,7 @@
         <p:cNvPr id="1" name="">
           <a:extLst>
             <a:ext uri="{FF2B5EF4-FFF2-40B4-BE49-F238E27FC236}">
-              <a16:creationId xmlns:a16="http://schemas.microsoft.com/office/drawing/2014/main" id="{2D44A6CC-3F0E-4271-B01F-5FDC554B2AF0}"/>
+              <a16:creationId xmlns:a16="http://schemas.microsoft.com/office/drawing/2014/main" id="{9A6F8170-398A-C4FE-0B6E-41E0DD4443D6}"/>
             </a:ext>
           </a:extLst>
         </p:cNvPr>
@@ -18877,7 +20933,7 @@
           <p:cNvPr id="2" name="Title 1">
             <a:extLst>
               <a:ext uri="{FF2B5EF4-FFF2-40B4-BE49-F238E27FC236}">
-                <a16:creationId xmlns:a16="http://schemas.microsoft.com/office/drawing/2014/main" id="{587A217E-1F63-F22E-47EF-529A2F51477F}"/>
+                <a16:creationId xmlns:a16="http://schemas.microsoft.com/office/drawing/2014/main" id="{B27DFC1B-1554-2FC8-A7DE-018F63566324}"/>
               </a:ext>
             </a:extLst>
           </p:cNvPr>
@@ -18895,7 +20951,88 @@
           <a:p>
             <a:r>
               <a:rPr lang="en-US" dirty="0"/>
-              <a:t>Acknowledgements</a:t>
+              <a:t>FANN charter text discussion</a:t>
+            </a:r>
+            <a:br>
+              <a:rPr lang="en-US" dirty="0"/>
+            </a:br>
+            <a:r>
+              <a:rPr lang="en-US" b="1" dirty="0"/>
+              <a:t>Expected Milestones</a:t>
+            </a:r>
+            <a:r>
+              <a:rPr lang="en-US" dirty="0"/>
+              <a:t> </a:t>
+            </a:r>
+          </a:p>
+        </p:txBody>
+      </p:sp>
+      <p:sp>
+        <p:nvSpPr>
+          <p:cNvPr id="3" name="Text Placeholder 2">
+            <a:extLst>
+              <a:ext uri="{FF2B5EF4-FFF2-40B4-BE49-F238E27FC236}">
+                <a16:creationId xmlns:a16="http://schemas.microsoft.com/office/drawing/2014/main" id="{07ED03F3-88AD-9E95-30B9-E574E9888F72}"/>
+              </a:ext>
+            </a:extLst>
+          </p:cNvPr>
+          <p:cNvSpPr>
+            <a:spLocks noGrp="1"/>
+          </p:cNvSpPr>
+          <p:nvPr>
+            <p:ph type="body" idx="1"/>
+          </p:nvPr>
+        </p:nvSpPr>
+        <p:spPr/>
+        <p:txBody>
+          <a:bodyPr/>
+          <a:lstStyle/>
+          <a:p>
+            <a:pPr marL="342900" indent="-228600">
+              <a:buSzPct val="100000"/>
+              <a:buFont typeface="+mj-lt"/>
+              <a:buAutoNum type="arabicPeriod"/>
+            </a:pPr>
+            <a:r>
+              <a:rPr lang="en-US" sz="1600" dirty="0"/>
+              <a:t>Requirements and Gap Analysis</a:t>
+            </a:r>
+          </a:p>
+          <a:p>
+            <a:pPr marL="342900" indent="-228600">
+              <a:buFont typeface="+mj-lt"/>
+              <a:buAutoNum type="arabicPeriod"/>
+            </a:pPr>
+            <a:endParaRPr lang="en-US" sz="1600" dirty="0"/>
+          </a:p>
+          <a:p>
+            <a:pPr marL="342900" indent="-228600">
+              <a:buSzPct val="100000"/>
+              <a:buFont typeface="+mj-lt"/>
+              <a:buAutoNum type="arabicPeriod"/>
+            </a:pPr>
+            <a:r>
+              <a:rPr lang="en-US" sz="1600" dirty="0"/>
+              <a:t>Fast Network Notification Information Model</a:t>
+            </a:r>
+          </a:p>
+          <a:p>
+            <a:pPr marL="342900" indent="-228600">
+              <a:buSzPct val="100000"/>
+              <a:buFont typeface="+mj-lt"/>
+              <a:buAutoNum type="arabicPeriod"/>
+            </a:pPr>
+            <a:endParaRPr lang="en-US" sz="1600" dirty="0"/>
+          </a:p>
+          <a:p>
+            <a:pPr marL="342900" indent="-228600">
+              <a:buSzPct val="100000"/>
+              <a:buFont typeface="+mj-lt"/>
+              <a:buAutoNum type="arabicPeriod"/>
+            </a:pPr>
+            <a:r>
+              <a:rPr lang="en-US" sz="1600" dirty="0"/>
+              <a:t>Fast Network Notification Protocol Specifications</a:t>
             </a:r>
           </a:p>
         </p:txBody>
@@ -18905,7 +21042,7 @@
           <p:cNvPr id="4" name="Slide Number Placeholder 3">
             <a:extLst>
               <a:ext uri="{FF2B5EF4-FFF2-40B4-BE49-F238E27FC236}">
-                <a16:creationId xmlns:a16="http://schemas.microsoft.com/office/drawing/2014/main" id="{D352032F-3F3B-B75A-E937-3D05E41AEE62}"/>
+                <a16:creationId xmlns:a16="http://schemas.microsoft.com/office/drawing/2014/main" id="{05A4D93B-B255-FE87-7F9E-1C4F7C5F405C}"/>
               </a:ext>
             </a:extLst>
           </p:cNvPr>
@@ -18938,85 +21075,10 @@
           </a:p>
         </p:txBody>
       </p:sp>
-      <p:sp>
-        <p:nvSpPr>
-          <p:cNvPr id="6" name="Text Placeholder 5">
-            <a:extLst>
-              <a:ext uri="{FF2B5EF4-FFF2-40B4-BE49-F238E27FC236}">
-                <a16:creationId xmlns:a16="http://schemas.microsoft.com/office/drawing/2014/main" id="{66FA077B-8A48-942A-00C5-E6BCC4EB33BB}"/>
-              </a:ext>
-            </a:extLst>
-          </p:cNvPr>
-          <p:cNvSpPr>
-            <a:spLocks noGrp="1"/>
-          </p:cNvSpPr>
-          <p:nvPr>
-            <p:ph type="body" idx="1"/>
-          </p:nvPr>
-        </p:nvSpPr>
-        <p:spPr>
-          <a:xfrm>
-            <a:off x="538800" y="1802552"/>
-            <a:ext cx="8066400" cy="2710125"/>
-          </a:xfrm>
-        </p:spPr>
-        <p:txBody>
-          <a:bodyPr/>
-          <a:lstStyle/>
-          <a:p>
-            <a:r>
-              <a:rPr lang="en-US" dirty="0"/>
-              <a:t>Thanks to Adrian Farrel, </a:t>
-            </a:r>
-            <a:r>
-              <a:rPr lang="en-CA" dirty="0"/>
-              <a:t>Joel Halpern</a:t>
-            </a:r>
-            <a:r>
-              <a:rPr lang="en-US" dirty="0"/>
-              <a:t>, </a:t>
-            </a:r>
-            <a:r>
-              <a:rPr lang="en-CA" dirty="0"/>
-              <a:t>Tal Mizrahi </a:t>
-            </a:r>
-            <a:r>
-              <a:rPr lang="en-US" dirty="0"/>
-              <a:t>, </a:t>
-            </a:r>
-            <a:r>
-              <a:rPr lang="en-CA" dirty="0" err="1"/>
-              <a:t>Yongqing</a:t>
-            </a:r>
-            <a:r>
-              <a:rPr lang="en-CA" dirty="0"/>
-              <a:t> Zhu, Carlos Jesus Bernardos </a:t>
-            </a:r>
-            <a:r>
-              <a:rPr lang="en-CA" dirty="0" err="1"/>
-              <a:t>Cano</a:t>
-            </a:r>
-            <a:r>
-              <a:rPr lang="en-CA" dirty="0"/>
-              <a:t>, Jiayuan Hu, et al.,  </a:t>
-            </a:r>
-            <a:r>
-              <a:rPr lang="en-US" dirty="0"/>
-              <a:t>for the review of the Charter text on the mailing list</a:t>
-            </a:r>
-          </a:p>
-          <a:p>
-            <a:r>
-              <a:rPr lang="en-US" dirty="0"/>
-              <a:t>Thanks to Jie Dong for addressing many review comments received – updates are work in progress</a:t>
-            </a:r>
-          </a:p>
-        </p:txBody>
-      </p:sp>
     </p:spTree>
     <p:extLst>
       <p:ext uri="{BB962C8B-B14F-4D97-AF65-F5344CB8AC3E}">
-        <p14:creationId xmlns:p14="http://schemas.microsoft.com/office/powerpoint/2010/main" val="3462364297"/>
+        <p14:creationId xmlns:p14="http://schemas.microsoft.com/office/powerpoint/2010/main" val="3240806239"/>
       </p:ext>
     </p:extLst>
   </p:cSld>

</xml_diff>